<commit_message>
Update ManageEngine roadmap per 28-Oct call
Realign release windows, club agent/agentless pilot and rollout milestones,
move Tenable and NetBox to TBD, shift CMDB feeds to Jan-27 and add the
Golden Asset Record milestone.

Co-Authored-By: Claude Opus 5.5 <noreply@anthropic.com>
Claude-Session: https://claude.ai/code/session_01YRFgXpWYZpZNdiR4z24WSz
</commit_message>
<xml_diff>
--- a/ManageEngine_Technical_Delivery_Roadmap.pptx
+++ b/ManageEngine_Technical_Delivery_Roadmap.pptx
@@ -107,7 +107,7 @@
   <p:extLst>
     <p:ext uri="{521415D9-36F7-43E2-AB2F-B90AF26B5E84}">
       <p14:sectionLst xmlns:p14="http://schemas.microsoft.com/office/powerpoint/2010/main">
-        <p14:section name="Roadmap" id="{eb263892-b7a2-a78b-660c-cf51115e60df}">
+        <p14:section name="Roadmap" id="{68876dd5-04b5-6d8b-9379-0e14e6e85555}">
           <p14:sldIdLst>
             <p14:sldId id="256"/>
           </p14:sldIdLst>
@@ -516,7 +516,7 @@
           <a:p>
             <a:r>
               <a:rPr lang="en-US" dirty="0"/>
-              <a:t>Source: ManageEngine_Interface_Tracker_v2.xlsx. Each interface is placed in the month of its planned End date and coloured by the release window that month falls in (≤Dec-26 Release 1, Jan–Feb-27 Release 2, Mar–May-27 Release 3). Phase = TBD items sit in the Future / TBD column.</a:t>
+              <a:t>Source: ManageEngine_Interface_Tracker_v2.xlsx. Each interface is placed in the month of its planned End date and coloured by the release window that month falls in (Oct–Dec-26 Release 1, Jan–Mar-27 Release 2, Apr–Jun-27 Release 3). Phase = TBD items sit in the Future / TBD column. Updated per 28-Oct-2026 call with Jacinta Undy: release windows realigned; agent/agentless pilot (Nov) and rollout (Dec, contingency Jan) clubbed; Tenable and NetBox moved to TBD; CMDB/asset-list feeds (Intune, SCCM, Lansweeper, NTT CMDB) moved to start of Release 2 (Jan-27); Golden Asset Record milestone added for end of Jan-27 (contingency Feb). The Golden Asset Record depends on the asset integrations, which depend on the full agent/agentless rollout.</a:t>
             </a:r>
             <a:endParaRPr lang="en-US" dirty="0"/>
           </a:p>
@@ -1114,7 +1114,7 @@
         <p:spPr>
           <a:xfrm>
             <a:off x="320040" y="841248"/>
-            <a:ext cx="10259568" cy="566928"/>
+            <a:ext cx="10259568" cy="329184"/>
           </a:xfrm>
           <a:prstGeom prst="rect">
             <a:avLst/>
@@ -1139,7 +1139,7 @@
         <p:spPr>
           <a:xfrm>
             <a:off x="429768" y="841248"/>
-            <a:ext cx="1600200" cy="566928"/>
+            <a:ext cx="1600200" cy="329184"/>
           </a:xfrm>
           <a:prstGeom prst="rect">
             <a:avLst/>
@@ -1178,7 +1178,7 @@
         <p:spPr>
           <a:xfrm>
             <a:off x="2103120" y="841248"/>
-            <a:ext cx="0" cy="566928"/>
+            <a:ext cx="0" cy="329184"/>
           </a:xfrm>
           <a:prstGeom prst="line">
             <a:avLst/>
@@ -1201,7 +1201,7 @@
         <p:spPr>
           <a:xfrm>
             <a:off x="3044952" y="841248"/>
-            <a:ext cx="0" cy="566928"/>
+            <a:ext cx="0" cy="329184"/>
           </a:xfrm>
           <a:prstGeom prst="line">
             <a:avLst/>
@@ -1224,7 +1224,7 @@
         <p:spPr>
           <a:xfrm>
             <a:off x="3986784" y="841248"/>
-            <a:ext cx="0" cy="566928"/>
+            <a:ext cx="0" cy="329184"/>
           </a:xfrm>
           <a:prstGeom prst="line">
             <a:avLst/>
@@ -1247,7 +1247,7 @@
         <p:spPr>
           <a:xfrm>
             <a:off x="4928616" y="841248"/>
-            <a:ext cx="0" cy="566928"/>
+            <a:ext cx="0" cy="329184"/>
           </a:xfrm>
           <a:prstGeom prst="line">
             <a:avLst/>
@@ -1270,7 +1270,7 @@
         <p:spPr>
           <a:xfrm>
             <a:off x="5870448" y="841248"/>
-            <a:ext cx="0" cy="566928"/>
+            <a:ext cx="0" cy="329184"/>
           </a:xfrm>
           <a:prstGeom prst="line">
             <a:avLst/>
@@ -1293,7 +1293,7 @@
         <p:spPr>
           <a:xfrm>
             <a:off x="6812280" y="841248"/>
-            <a:ext cx="0" cy="566928"/>
+            <a:ext cx="0" cy="329184"/>
           </a:xfrm>
           <a:prstGeom prst="line">
             <a:avLst/>
@@ -1316,7 +1316,7 @@
         <p:spPr>
           <a:xfrm>
             <a:off x="7754112" y="841248"/>
-            <a:ext cx="0" cy="566928"/>
+            <a:ext cx="0" cy="329184"/>
           </a:xfrm>
           <a:prstGeom prst="line">
             <a:avLst/>
@@ -1339,7 +1339,7 @@
         <p:spPr>
           <a:xfrm>
             <a:off x="8695944" y="841248"/>
-            <a:ext cx="0" cy="566928"/>
+            <a:ext cx="0" cy="329184"/>
           </a:xfrm>
           <a:prstGeom prst="line">
             <a:avLst/>
@@ -1362,7 +1362,7 @@
         <p:spPr>
           <a:xfrm>
             <a:off x="9637776" y="841248"/>
-            <a:ext cx="0" cy="566928"/>
+            <a:ext cx="0" cy="329184"/>
           </a:xfrm>
           <a:prstGeom prst="line">
             <a:avLst/>
@@ -1385,7 +1385,7 @@
         <p:spPr>
           <a:xfrm>
             <a:off x="10579608" y="841248"/>
-            <a:ext cx="0" cy="566928"/>
+            <a:ext cx="0" cy="329184"/>
           </a:xfrm>
           <a:prstGeom prst="line">
             <a:avLst/>
@@ -1407,12 +1407,12 @@
         </p:nvSpPr>
         <p:spPr>
           <a:xfrm>
-            <a:off x="2139696" y="877824"/>
-            <a:ext cx="2752344" cy="155448"/>
+            <a:off x="2139696" y="905256"/>
+            <a:ext cx="2752344" cy="201168"/>
           </a:xfrm>
           <a:prstGeom prst="roundRect">
             <a:avLst>
-              <a:gd name="adj" fmla="val 23529"/>
+              <a:gd name="adj" fmla="val 18182"/>
             </a:avLst>
           </a:prstGeom>
           <a:solidFill>
@@ -1434,8 +1434,8 @@
         </p:nvSpPr>
         <p:spPr>
           <a:xfrm>
-            <a:off x="2139696" y="877824"/>
-            <a:ext cx="2752344" cy="155448"/>
+            <a:off x="2139696" y="905256"/>
+            <a:ext cx="2752344" cy="201168"/>
           </a:xfrm>
           <a:prstGeom prst="rect">
             <a:avLst/>
@@ -1451,9 +1451,9 @@
               <a:buNone/>
             </a:pPr>
             <a:r>
-              <a:rPr lang="en-US" sz="1000" b="1" dirty="0">
-                <a:solidFill>
-                  <a:srgbClr val="FFFFFF"/>
+              <a:rPr lang="en-US" sz="1100" b="1" dirty="0">
+                <a:solidFill>
+                  <a:srgbClr val="14285A"/>
                 </a:solidFill>
                 <a:latin typeface="Calibri" pitchFamily="34" charset="0"/>
                 <a:ea typeface="Calibri" pitchFamily="34" charset="-122"/>
@@ -1467,7 +1467,7 @@
             <a:r>
               <a:rPr lang="en-US" sz="900" dirty="0">
                 <a:solidFill>
-                  <a:srgbClr val="FFFFFF"/>
+                  <a:srgbClr val="14285A"/>
                 </a:solidFill>
                 <a:latin typeface="Calibri" pitchFamily="34" charset="0"/>
                 <a:ea typeface="Calibri" pitchFamily="34" charset="-122"/>
@@ -1475,7 +1475,7 @@
               </a:rPr>
               <a:t>Oct 2026 – Dec 2026</a:t>
             </a:r>
-            <a:endParaRPr lang="en-US" sz="1000" dirty="0"/>
+            <a:endParaRPr lang="en-US" sz="1100" dirty="0"/>
           </a:p>
         </p:txBody>
       </p:sp>
@@ -1487,12 +1487,12 @@
         </p:nvSpPr>
         <p:spPr>
           <a:xfrm>
-            <a:off x="3081528" y="1051560"/>
-            <a:ext cx="3694176" cy="155448"/>
+            <a:off x="4965192" y="905256"/>
+            <a:ext cx="2752344" cy="201168"/>
           </a:xfrm>
           <a:prstGeom prst="roundRect">
             <a:avLst>
-              <a:gd name="adj" fmla="val 23529"/>
+              <a:gd name="adj" fmla="val 18182"/>
             </a:avLst>
           </a:prstGeom>
           <a:solidFill>
@@ -1514,8 +1514,8 @@
         </p:nvSpPr>
         <p:spPr>
           <a:xfrm>
-            <a:off x="3081528" y="1051560"/>
-            <a:ext cx="3694176" cy="155448"/>
+            <a:off x="4965192" y="905256"/>
+            <a:ext cx="2752344" cy="201168"/>
           </a:xfrm>
           <a:prstGeom prst="rect">
             <a:avLst/>
@@ -1531,7 +1531,7 @@
               <a:buNone/>
             </a:pPr>
             <a:r>
-              <a:rPr lang="en-US" sz="1000" b="1" dirty="0">
+              <a:rPr lang="en-US" sz="1100" b="1" dirty="0">
                 <a:solidFill>
                   <a:srgbClr val="14285A"/>
                 </a:solidFill>
@@ -1553,9 +1553,9 @@
                 <a:ea typeface="Calibri" pitchFamily="34" charset="-122"/>
                 <a:cs typeface="Calibri" pitchFamily="34" charset="-120"/>
               </a:rPr>
-              <a:t>Nov 2026 – Feb 2027</a:t>
-            </a:r>
-            <a:endParaRPr lang="en-US" sz="1000" dirty="0"/>
+              <a:t>Jan 2027 – Mar 2027</a:t>
+            </a:r>
+            <a:endParaRPr lang="en-US" sz="1100" dirty="0"/>
           </a:p>
         </p:txBody>
       </p:sp>
@@ -1567,12 +1567,12 @@
         </p:nvSpPr>
         <p:spPr>
           <a:xfrm>
-            <a:off x="4965192" y="1225296"/>
-            <a:ext cx="4636008" cy="155448"/>
+            <a:off x="7790688" y="905256"/>
+            <a:ext cx="2752344" cy="201168"/>
           </a:xfrm>
           <a:prstGeom prst="roundRect">
             <a:avLst>
-              <a:gd name="adj" fmla="val 23529"/>
+              <a:gd name="adj" fmla="val 18182"/>
             </a:avLst>
           </a:prstGeom>
           <a:solidFill>
@@ -1594,8 +1594,8 @@
         </p:nvSpPr>
         <p:spPr>
           <a:xfrm>
-            <a:off x="4965192" y="1225296"/>
-            <a:ext cx="4636008" cy="155448"/>
+            <a:off x="7790688" y="905256"/>
+            <a:ext cx="2752344" cy="201168"/>
           </a:xfrm>
           <a:prstGeom prst="rect">
             <a:avLst/>
@@ -1611,7 +1611,7 @@
               <a:buNone/>
             </a:pPr>
             <a:r>
-              <a:rPr lang="en-US" sz="1000" b="1" dirty="0">
+              <a:rPr lang="en-US" sz="1100" b="1" dirty="0">
                 <a:solidFill>
                   <a:srgbClr val="2A1B5E"/>
                 </a:solidFill>
@@ -1633,9 +1633,9 @@
                 <a:ea typeface="Calibri" pitchFamily="34" charset="-122"/>
                 <a:cs typeface="Calibri" pitchFamily="34" charset="-120"/>
               </a:rPr>
-              <a:t>Jan 2027 – May 2027</a:t>
-            </a:r>
-            <a:endParaRPr lang="en-US" sz="1000" dirty="0"/>
+              <a:t>Apr 2027 – Jun 2027</a:t>
+            </a:r>
+            <a:endParaRPr lang="en-US" sz="1100" dirty="0"/>
           </a:p>
         </p:txBody>
       </p:sp>
@@ -1647,7 +1647,7 @@
         </p:nvSpPr>
         <p:spPr>
           <a:xfrm>
-            <a:off x="320040" y="1463040"/>
+            <a:off x="320040" y="1243584"/>
             <a:ext cx="10259568" cy="237744"/>
           </a:xfrm>
           <a:prstGeom prst="rect">
@@ -1672,7 +1672,7 @@
         </p:nvSpPr>
         <p:spPr>
           <a:xfrm>
-            <a:off x="429768" y="1463040"/>
+            <a:off x="429768" y="1243584"/>
             <a:ext cx="1673352" cy="237744"/>
           </a:xfrm>
           <a:prstGeom prst="rect">
@@ -1711,7 +1711,7 @@
         </p:nvSpPr>
         <p:spPr>
           <a:xfrm>
-            <a:off x="2103120" y="1463040"/>
+            <a:off x="2103120" y="1243584"/>
             <a:ext cx="941832" cy="237744"/>
           </a:xfrm>
           <a:prstGeom prst="rect">
@@ -1750,7 +1750,7 @@
         </p:nvSpPr>
         <p:spPr>
           <a:xfrm>
-            <a:off x="3044952" y="1463040"/>
+            <a:off x="3044952" y="1243584"/>
             <a:ext cx="941832" cy="237744"/>
           </a:xfrm>
           <a:prstGeom prst="rect">
@@ -1789,7 +1789,7 @@
         </p:nvSpPr>
         <p:spPr>
           <a:xfrm>
-            <a:off x="3986784" y="1463040"/>
+            <a:off x="3986784" y="1243584"/>
             <a:ext cx="941832" cy="237744"/>
           </a:xfrm>
           <a:prstGeom prst="rect">
@@ -1828,7 +1828,7 @@
         </p:nvSpPr>
         <p:spPr>
           <a:xfrm>
-            <a:off x="4928616" y="1463040"/>
+            <a:off x="4928616" y="1243584"/>
             <a:ext cx="941832" cy="237744"/>
           </a:xfrm>
           <a:prstGeom prst="rect">
@@ -1867,7 +1867,7 @@
         </p:nvSpPr>
         <p:spPr>
           <a:xfrm>
-            <a:off x="5870448" y="1463040"/>
+            <a:off x="5870448" y="1243584"/>
             <a:ext cx="941832" cy="237744"/>
           </a:xfrm>
           <a:prstGeom prst="rect">
@@ -1906,7 +1906,7 @@
         </p:nvSpPr>
         <p:spPr>
           <a:xfrm>
-            <a:off x="6812280" y="1463040"/>
+            <a:off x="6812280" y="1243584"/>
             <a:ext cx="941832" cy="237744"/>
           </a:xfrm>
           <a:prstGeom prst="rect">
@@ -1945,7 +1945,7 @@
         </p:nvSpPr>
         <p:spPr>
           <a:xfrm>
-            <a:off x="7754112" y="1463040"/>
+            <a:off x="7754112" y="1243584"/>
             <a:ext cx="941832" cy="237744"/>
           </a:xfrm>
           <a:prstGeom prst="rect">
@@ -1984,7 +1984,7 @@
         </p:nvSpPr>
         <p:spPr>
           <a:xfrm>
-            <a:off x="8695944" y="1463040"/>
+            <a:off x="8695944" y="1243584"/>
             <a:ext cx="941832" cy="237744"/>
           </a:xfrm>
           <a:prstGeom prst="rect">
@@ -2023,7 +2023,7 @@
         </p:nvSpPr>
         <p:spPr>
           <a:xfrm>
-            <a:off x="9637776" y="1463040"/>
+            <a:off x="9637776" y="1243584"/>
             <a:ext cx="941832" cy="237744"/>
           </a:xfrm>
           <a:prstGeom prst="rect">
@@ -2062,8 +2062,8 @@
         </p:nvSpPr>
         <p:spPr>
           <a:xfrm>
-            <a:off x="10652760" y="1463040"/>
-            <a:ext cx="1216152" cy="4041648"/>
+            <a:off x="10652760" y="1243584"/>
+            <a:ext cx="1216152" cy="4027018"/>
           </a:xfrm>
           <a:prstGeom prst="rect">
             <a:avLst/>
@@ -2087,7 +2087,7 @@
         </p:nvSpPr>
         <p:spPr>
           <a:xfrm>
-            <a:off x="10652760" y="1463040"/>
+            <a:off x="10652760" y="1243584"/>
             <a:ext cx="1216152" cy="237744"/>
           </a:xfrm>
           <a:prstGeom prst="rect">
@@ -2112,7 +2112,7 @@
         </p:nvSpPr>
         <p:spPr>
           <a:xfrm>
-            <a:off x="10652760" y="1463040"/>
+            <a:off x="10652760" y="1243584"/>
             <a:ext cx="1216152" cy="237744"/>
           </a:xfrm>
           <a:prstGeom prst="rect">
@@ -2151,8 +2151,8 @@
         </p:nvSpPr>
         <p:spPr>
           <a:xfrm>
-            <a:off x="320040" y="1700784"/>
-            <a:ext cx="10259568" cy="493776"/>
+            <a:off x="320040" y="1481328"/>
+            <a:ext cx="10259568" cy="534010"/>
           </a:xfrm>
           <a:prstGeom prst="rect">
             <a:avLst/>
@@ -2176,7 +2176,7 @@
         </p:nvSpPr>
         <p:spPr>
           <a:xfrm>
-            <a:off x="10652760" y="2194560"/>
+            <a:off x="10652760" y="2015338"/>
             <a:ext cx="1216152" cy="0"/>
           </a:xfrm>
           <a:prstGeom prst="line">
@@ -2207,7 +2207,7 @@
         </p:blipFill>
         <p:spPr>
           <a:xfrm>
-            <a:off x="429768" y="1828800"/>
+            <a:off x="429768" y="1629461"/>
             <a:ext cx="237744" cy="237744"/>
           </a:xfrm>
           <a:prstGeom prst="rect">
@@ -2223,8 +2223,8 @@
         </p:nvSpPr>
         <p:spPr>
           <a:xfrm>
-            <a:off x="777240" y="1700784"/>
-            <a:ext cx="1307592" cy="493776"/>
+            <a:off x="777240" y="1481328"/>
+            <a:ext cx="1307592" cy="534010"/>
           </a:xfrm>
           <a:prstGeom prst="rect">
             <a:avLst/>
@@ -2279,12 +2279,12 @@
         </p:nvSpPr>
         <p:spPr>
           <a:xfrm>
-            <a:off x="3081528" y="1810512"/>
-            <a:ext cx="868680" cy="128016"/>
+            <a:off x="3081528" y="1601114"/>
+            <a:ext cx="868680" cy="137160"/>
           </a:xfrm>
           <a:prstGeom prst="roundRect">
             <a:avLst>
-              <a:gd name="adj" fmla="val 21429"/>
+              <a:gd name="adj" fmla="val 20000"/>
             </a:avLst>
           </a:prstGeom>
           <a:solidFill>
@@ -2304,7 +2304,7 @@
               <a:buNone/>
             </a:pPr>
             <a:r>
-              <a:rPr lang="en-US" sz="800" dirty="0">
+              <a:rPr lang="en-US" sz="850" dirty="0">
                 <a:solidFill>
                   <a:srgbClr val="14285A"/>
                 </a:solidFill>
@@ -2314,7 +2314,7 @@
               </a:rPr>
               <a:t>Entra ID</a:t>
             </a:r>
-            <a:endParaRPr lang="en-US" sz="800" dirty="0"/>
+            <a:endParaRPr lang="en-US" sz="850" dirty="0"/>
           </a:p>
         </p:txBody>
       </p:sp>
@@ -2326,12 +2326,12 @@
         </p:nvSpPr>
         <p:spPr>
           <a:xfrm>
-            <a:off x="3081528" y="1956816"/>
-            <a:ext cx="868680" cy="128016"/>
+            <a:off x="3081528" y="1758391"/>
+            <a:ext cx="868680" cy="137160"/>
           </a:xfrm>
           <a:prstGeom prst="roundRect">
             <a:avLst>
-              <a:gd name="adj" fmla="val 21429"/>
+              <a:gd name="adj" fmla="val 20000"/>
             </a:avLst>
           </a:prstGeom>
           <a:solidFill>
@@ -2351,7 +2351,7 @@
               <a:buNone/>
             </a:pPr>
             <a:r>
-              <a:rPr lang="en-US" sz="800" dirty="0">
+              <a:rPr lang="en-US" sz="850" dirty="0">
                 <a:solidFill>
                   <a:srgbClr val="14285A"/>
                 </a:solidFill>
@@ -2361,7 +2361,7 @@
               </a:rPr>
               <a:t>Active Directory</a:t>
             </a:r>
-            <a:endParaRPr lang="en-US" sz="800" dirty="0"/>
+            <a:endParaRPr lang="en-US" sz="850" dirty="0"/>
           </a:p>
         </p:txBody>
       </p:sp>
@@ -2373,12 +2373,12 @@
         </p:nvSpPr>
         <p:spPr>
           <a:xfrm>
-            <a:off x="5907024" y="1737360"/>
-            <a:ext cx="868680" cy="128016"/>
+            <a:off x="5907024" y="1522476"/>
+            <a:ext cx="868680" cy="137160"/>
           </a:xfrm>
           <a:prstGeom prst="roundRect">
             <a:avLst>
-              <a:gd name="adj" fmla="val 21429"/>
+              <a:gd name="adj" fmla="val 20000"/>
             </a:avLst>
           </a:prstGeom>
           <a:solidFill>
@@ -2398,7 +2398,7 @@
               <a:buNone/>
             </a:pPr>
             <a:r>
-              <a:rPr lang="en-US" sz="800" dirty="0">
+              <a:rPr lang="en-US" sz="850" dirty="0">
                 <a:solidFill>
                   <a:srgbClr val="0F3F38"/>
                 </a:solidFill>
@@ -2408,7 +2408,7 @@
               </a:rPr>
               <a:t>Workday</a:t>
             </a:r>
-            <a:endParaRPr lang="en-US" sz="800" dirty="0"/>
+            <a:endParaRPr lang="en-US" sz="850" dirty="0"/>
           </a:p>
         </p:txBody>
       </p:sp>
@@ -2420,12 +2420,12 @@
         </p:nvSpPr>
         <p:spPr>
           <a:xfrm>
-            <a:off x="5907024" y="1883664"/>
-            <a:ext cx="868680" cy="128016"/>
+            <a:off x="5907024" y="1679753"/>
+            <a:ext cx="868680" cy="137160"/>
           </a:xfrm>
           <a:prstGeom prst="roundRect">
             <a:avLst>
-              <a:gd name="adj" fmla="val 21429"/>
+              <a:gd name="adj" fmla="val 20000"/>
             </a:avLst>
           </a:prstGeom>
           <a:solidFill>
@@ -2445,7 +2445,7 @@
               <a:buNone/>
             </a:pPr>
             <a:r>
-              <a:rPr lang="en-US" sz="800" dirty="0">
+              <a:rPr lang="en-US" sz="850" dirty="0">
                 <a:solidFill>
                   <a:srgbClr val="0F3F38"/>
                 </a:solidFill>
@@ -2455,7 +2455,7 @@
               </a:rPr>
               <a:t>UKG</a:t>
             </a:r>
-            <a:endParaRPr lang="en-US" sz="800" dirty="0"/>
+            <a:endParaRPr lang="en-US" sz="850" dirty="0"/>
           </a:p>
         </p:txBody>
       </p:sp>
@@ -2467,12 +2467,12 @@
         </p:nvSpPr>
         <p:spPr>
           <a:xfrm>
-            <a:off x="5907024" y="2029968"/>
-            <a:ext cx="868680" cy="128016"/>
+            <a:off x="5907024" y="1837030"/>
+            <a:ext cx="868680" cy="137160"/>
           </a:xfrm>
           <a:prstGeom prst="roundRect">
             <a:avLst>
-              <a:gd name="adj" fmla="val 21429"/>
+              <a:gd name="adj" fmla="val 20000"/>
             </a:avLst>
           </a:prstGeom>
           <a:solidFill>
@@ -2492,7 +2492,7 @@
               <a:buNone/>
             </a:pPr>
             <a:r>
-              <a:rPr lang="en-US" sz="800" dirty="0">
+              <a:rPr lang="en-US" sz="850" dirty="0">
                 <a:solidFill>
                   <a:srgbClr val="0F3F38"/>
                 </a:solidFill>
@@ -2502,7 +2502,7 @@
               </a:rPr>
               <a:t>Okta</a:t>
             </a:r>
-            <a:endParaRPr lang="en-US" sz="800" dirty="0"/>
+            <a:endParaRPr lang="en-US" sz="850" dirty="0"/>
           </a:p>
         </p:txBody>
       </p:sp>
@@ -2514,8 +2514,8 @@
         </p:nvSpPr>
         <p:spPr>
           <a:xfrm>
-            <a:off x="320040" y="2194560"/>
-            <a:ext cx="10259568" cy="347472"/>
+            <a:off x="320040" y="2015338"/>
+            <a:ext cx="10259568" cy="376733"/>
           </a:xfrm>
           <a:prstGeom prst="rect">
             <a:avLst/>
@@ -2539,7 +2539,7 @@
         </p:nvSpPr>
         <p:spPr>
           <a:xfrm>
-            <a:off x="10652760" y="2542032"/>
+            <a:off x="10652760" y="2392070"/>
             <a:ext cx="1216152" cy="0"/>
           </a:xfrm>
           <a:prstGeom prst="line">
@@ -2570,7 +2570,7 @@
         </p:blipFill>
         <p:spPr>
           <a:xfrm>
-            <a:off x="429768" y="2249424"/>
+            <a:off x="429768" y="2084832"/>
             <a:ext cx="237744" cy="237744"/>
           </a:xfrm>
           <a:prstGeom prst="rect">
@@ -2586,8 +2586,8 @@
         </p:nvSpPr>
         <p:spPr>
           <a:xfrm>
-            <a:off x="777240" y="2194560"/>
-            <a:ext cx="1307592" cy="347472"/>
+            <a:off x="777240" y="2015338"/>
+            <a:ext cx="1307592" cy="376733"/>
           </a:xfrm>
           <a:prstGeom prst="rect">
             <a:avLst/>
@@ -2642,12 +2642,12 @@
         </p:nvSpPr>
         <p:spPr>
           <a:xfrm>
-            <a:off x="3081528" y="2231136"/>
-            <a:ext cx="868680" cy="128016"/>
+            <a:off x="3081528" y="2056486"/>
+            <a:ext cx="868680" cy="137160"/>
           </a:xfrm>
           <a:prstGeom prst="roundRect">
             <a:avLst>
-              <a:gd name="adj" fmla="val 21429"/>
+              <a:gd name="adj" fmla="val 20000"/>
             </a:avLst>
           </a:prstGeom>
           <a:solidFill>
@@ -2667,7 +2667,7 @@
               <a:buNone/>
             </a:pPr>
             <a:r>
-              <a:rPr lang="en-US" sz="800" dirty="0">
+              <a:rPr lang="en-US" sz="850" dirty="0">
                 <a:solidFill>
                   <a:srgbClr val="14285A"/>
                 </a:solidFill>
@@ -2677,7 +2677,7 @@
               </a:rPr>
               <a:t>Teams</a:t>
             </a:r>
-            <a:endParaRPr lang="en-US" sz="800" dirty="0"/>
+            <a:endParaRPr lang="en-US" sz="850" dirty="0"/>
           </a:p>
         </p:txBody>
       </p:sp>
@@ -2689,12 +2689,12 @@
         </p:nvSpPr>
         <p:spPr>
           <a:xfrm>
-            <a:off x="3081528" y="2377440"/>
-            <a:ext cx="868680" cy="128016"/>
+            <a:off x="3081528" y="2213762"/>
+            <a:ext cx="868680" cy="137160"/>
           </a:xfrm>
           <a:prstGeom prst="roundRect">
             <a:avLst>
-              <a:gd name="adj" fmla="val 21429"/>
+              <a:gd name="adj" fmla="val 20000"/>
             </a:avLst>
           </a:prstGeom>
           <a:solidFill>
@@ -2714,7 +2714,7 @@
               <a:buNone/>
             </a:pPr>
             <a:r>
-              <a:rPr lang="en-US" sz="800" dirty="0">
+              <a:rPr lang="en-US" sz="850" dirty="0">
                 <a:solidFill>
                   <a:srgbClr val="14285A"/>
                 </a:solidFill>
@@ -2724,7 +2724,7 @@
               </a:rPr>
               <a:t>Sinch SMS</a:t>
             </a:r>
-            <a:endParaRPr lang="en-US" sz="800" dirty="0"/>
+            <a:endParaRPr lang="en-US" sz="850" dirty="0"/>
           </a:p>
         </p:txBody>
       </p:sp>
@@ -2736,12 +2736,12 @@
         </p:nvSpPr>
         <p:spPr>
           <a:xfrm>
-            <a:off x="5907024" y="2304288"/>
-            <a:ext cx="868680" cy="128016"/>
+            <a:off x="5907024" y="2135124"/>
+            <a:ext cx="868680" cy="137160"/>
           </a:xfrm>
           <a:prstGeom prst="roundRect">
             <a:avLst>
-              <a:gd name="adj" fmla="val 21429"/>
+              <a:gd name="adj" fmla="val 20000"/>
             </a:avLst>
           </a:prstGeom>
           <a:solidFill>
@@ -2761,7 +2761,7 @@
               <a:buNone/>
             </a:pPr>
             <a:r>
-              <a:rPr lang="en-US" sz="800" dirty="0">
+              <a:rPr lang="en-US" sz="850" dirty="0">
                 <a:solidFill>
                   <a:srgbClr val="0F3F38"/>
                 </a:solidFill>
@@ -2771,7 +2771,7 @@
               </a:rPr>
               <a:t>Genesys</a:t>
             </a:r>
-            <a:endParaRPr lang="en-US" sz="800" dirty="0"/>
+            <a:endParaRPr lang="en-US" sz="850" dirty="0"/>
           </a:p>
         </p:txBody>
       </p:sp>
@@ -2783,8 +2783,8 @@
         </p:nvSpPr>
         <p:spPr>
           <a:xfrm>
-            <a:off x="320040" y="2542032"/>
-            <a:ext cx="10259568" cy="640080"/>
+            <a:off x="320040" y="2392070"/>
+            <a:ext cx="10259568" cy="534010"/>
           </a:xfrm>
           <a:prstGeom prst="rect">
             <a:avLst/>
@@ -2808,7 +2808,7 @@
         </p:nvSpPr>
         <p:spPr>
           <a:xfrm>
-            <a:off x="10652760" y="3182112"/>
+            <a:off x="10652760" y="2926080"/>
             <a:ext cx="1216152" cy="0"/>
           </a:xfrm>
           <a:prstGeom prst="line">
@@ -2839,7 +2839,7 @@
         </p:blipFill>
         <p:spPr>
           <a:xfrm>
-            <a:off x="429768" y="2743200"/>
+            <a:off x="429768" y="2540203"/>
             <a:ext cx="237744" cy="237744"/>
           </a:xfrm>
           <a:prstGeom prst="rect">
@@ -2855,8 +2855,8 @@
         </p:nvSpPr>
         <p:spPr>
           <a:xfrm>
-            <a:off x="777240" y="2542032"/>
-            <a:ext cx="1307592" cy="640080"/>
+            <a:off x="777240" y="2392070"/>
+            <a:ext cx="1307592" cy="534010"/>
           </a:xfrm>
           <a:prstGeom prst="rect">
             <a:avLst/>
@@ -2905,26 +2905,26 @@
       </p:sp>
       <p:sp>
         <p:nvSpPr>
-          <p:cNvPr id="56" name="Intune (Release 1)"/>
-          <p:cNvSpPr/>
-          <p:nvPr/>
-        </p:nvSpPr>
-        <p:spPr>
-          <a:xfrm>
-            <a:off x="4023360" y="2578608"/>
-            <a:ext cx="868680" cy="128016"/>
+          <p:cNvPr id="56" name="Intune (Release 2)"/>
+          <p:cNvSpPr/>
+          <p:nvPr/>
+        </p:nvSpPr>
+        <p:spPr>
+          <a:xfrm>
+            <a:off x="4965192" y="2433218"/>
+            <a:ext cx="868680" cy="137160"/>
           </a:xfrm>
           <a:prstGeom prst="roundRect">
             <a:avLst>
-              <a:gd name="adj" fmla="val 21429"/>
+              <a:gd name="adj" fmla="val 20000"/>
             </a:avLst>
           </a:prstGeom>
           <a:solidFill>
-            <a:srgbClr val="A9CBF2"/>
+            <a:srgbClr val="A8DCD1"/>
           </a:solidFill>
           <a:ln w="6350">
             <a:solidFill>
-              <a:srgbClr val="A9CBF2"/>
+              <a:srgbClr val="A8DCD1"/>
             </a:solidFill>
           </a:ln>
         </p:spPr>
@@ -2936,9 +2936,9 @@
               <a:buNone/>
             </a:pPr>
             <a:r>
-              <a:rPr lang="en-US" sz="800" dirty="0">
-                <a:solidFill>
-                  <a:srgbClr val="14285A"/>
+              <a:rPr lang="en-US" sz="850" dirty="0">
+                <a:solidFill>
+                  <a:srgbClr val="0F3F38"/>
                 </a:solidFill>
                 <a:latin typeface="Calibri" pitchFamily="34" charset="0"/>
                 <a:ea typeface="Calibri" pitchFamily="34" charset="-122"/>
@@ -2946,32 +2946,32 @@
               </a:rPr>
               <a:t>Intune</a:t>
             </a:r>
-            <a:endParaRPr lang="en-US" sz="800" dirty="0"/>
-          </a:p>
-        </p:txBody>
-      </p:sp>
-      <p:sp>
-        <p:nvSpPr>
-          <p:cNvPr id="57" name="SCCM (Release 1)"/>
-          <p:cNvSpPr/>
-          <p:nvPr/>
-        </p:nvSpPr>
-        <p:spPr>
-          <a:xfrm>
-            <a:off x="4023360" y="2724912"/>
-            <a:ext cx="868680" cy="128016"/>
+            <a:endParaRPr lang="en-US" sz="850" dirty="0"/>
+          </a:p>
+        </p:txBody>
+      </p:sp>
+      <p:sp>
+        <p:nvSpPr>
+          <p:cNvPr id="57" name="SCCM (Release 2)"/>
+          <p:cNvSpPr/>
+          <p:nvPr/>
+        </p:nvSpPr>
+        <p:spPr>
+          <a:xfrm>
+            <a:off x="4965192" y="2590495"/>
+            <a:ext cx="868680" cy="137160"/>
           </a:xfrm>
           <a:prstGeom prst="roundRect">
             <a:avLst>
-              <a:gd name="adj" fmla="val 21429"/>
+              <a:gd name="adj" fmla="val 20000"/>
             </a:avLst>
           </a:prstGeom>
           <a:solidFill>
-            <a:srgbClr val="A9CBF2"/>
+            <a:srgbClr val="A8DCD1"/>
           </a:solidFill>
           <a:ln w="6350">
             <a:solidFill>
-              <a:srgbClr val="A9CBF2"/>
+              <a:srgbClr val="A8DCD1"/>
             </a:solidFill>
           </a:ln>
         </p:spPr>
@@ -2983,9 +2983,9 @@
               <a:buNone/>
             </a:pPr>
             <a:r>
-              <a:rPr lang="en-US" sz="800" dirty="0">
-                <a:solidFill>
-                  <a:srgbClr val="14285A"/>
+              <a:rPr lang="en-US" sz="850" dirty="0">
+                <a:solidFill>
+                  <a:srgbClr val="0F3F38"/>
                 </a:solidFill>
                 <a:latin typeface="Calibri" pitchFamily="34" charset="0"/>
                 <a:ea typeface="Calibri" pitchFamily="34" charset="-122"/>
@@ -2993,32 +2993,32 @@
               </a:rPr>
               <a:t>SCCM</a:t>
             </a:r>
-            <a:endParaRPr lang="en-US" sz="800" dirty="0"/>
-          </a:p>
-        </p:txBody>
-      </p:sp>
-      <p:sp>
-        <p:nvSpPr>
-          <p:cNvPr id="58" name="Lansweeper (Release 1)"/>
-          <p:cNvSpPr/>
-          <p:nvPr/>
-        </p:nvSpPr>
-        <p:spPr>
-          <a:xfrm>
-            <a:off x="4023360" y="2871216"/>
-            <a:ext cx="868680" cy="128016"/>
+            <a:endParaRPr lang="en-US" sz="850" dirty="0"/>
+          </a:p>
+        </p:txBody>
+      </p:sp>
+      <p:sp>
+        <p:nvSpPr>
+          <p:cNvPr id="58" name="Lansweeper (Release 2)"/>
+          <p:cNvSpPr/>
+          <p:nvPr/>
+        </p:nvSpPr>
+        <p:spPr>
+          <a:xfrm>
+            <a:off x="4965192" y="2747772"/>
+            <a:ext cx="868680" cy="137160"/>
           </a:xfrm>
           <a:prstGeom prst="roundRect">
             <a:avLst>
-              <a:gd name="adj" fmla="val 21429"/>
+              <a:gd name="adj" fmla="val 20000"/>
             </a:avLst>
           </a:prstGeom>
           <a:solidFill>
-            <a:srgbClr val="A9CBF2"/>
+            <a:srgbClr val="A8DCD1"/>
           </a:solidFill>
           <a:ln w="6350">
             <a:solidFill>
-              <a:srgbClr val="A9CBF2"/>
+              <a:srgbClr val="A8DCD1"/>
             </a:solidFill>
           </a:ln>
         </p:spPr>
@@ -3030,9 +3030,9 @@
               <a:buNone/>
             </a:pPr>
             <a:r>
-              <a:rPr lang="en-US" sz="800" dirty="0">
-                <a:solidFill>
-                  <a:srgbClr val="14285A"/>
+              <a:rPr lang="en-US" sz="850" dirty="0">
+                <a:solidFill>
+                  <a:srgbClr val="0F3F38"/>
                 </a:solidFill>
                 <a:latin typeface="Calibri" pitchFamily="34" charset="0"/>
                 <a:ea typeface="Calibri" pitchFamily="34" charset="-122"/>
@@ -3040,32 +3040,32 @@
               </a:rPr>
               <a:t>Lansweeper</a:t>
             </a:r>
-            <a:endParaRPr lang="en-US" sz="800" dirty="0"/>
-          </a:p>
-        </p:txBody>
-      </p:sp>
-      <p:sp>
-        <p:nvSpPr>
-          <p:cNvPr id="59" name="NetBox (Release 1)"/>
-          <p:cNvSpPr/>
-          <p:nvPr/>
-        </p:nvSpPr>
-        <p:spPr>
-          <a:xfrm>
-            <a:off x="4023360" y="3017520"/>
-            <a:ext cx="868680" cy="128016"/>
+            <a:endParaRPr lang="en-US" sz="850" dirty="0"/>
+          </a:p>
+        </p:txBody>
+      </p:sp>
+      <p:sp>
+        <p:nvSpPr>
+          <p:cNvPr id="59" name="VMware vSphere (Release 2)"/>
+          <p:cNvSpPr/>
+          <p:nvPr/>
+        </p:nvSpPr>
+        <p:spPr>
+          <a:xfrm>
+            <a:off x="5907024" y="2433218"/>
+            <a:ext cx="868680" cy="137160"/>
           </a:xfrm>
           <a:prstGeom prst="roundRect">
             <a:avLst>
-              <a:gd name="adj" fmla="val 21429"/>
+              <a:gd name="adj" fmla="val 20000"/>
             </a:avLst>
           </a:prstGeom>
           <a:solidFill>
-            <a:srgbClr val="A9CBF2"/>
+            <a:srgbClr val="A8DCD1"/>
           </a:solidFill>
           <a:ln w="6350">
             <a:solidFill>
-              <a:srgbClr val="A9CBF2"/>
+              <a:srgbClr val="A8DCD1"/>
             </a:solidFill>
           </a:ln>
         </p:spPr>
@@ -3077,34 +3077,34 @@
               <a:buNone/>
             </a:pPr>
             <a:r>
-              <a:rPr lang="en-US" sz="800" dirty="0">
-                <a:solidFill>
-                  <a:srgbClr val="14285A"/>
-                </a:solidFill>
-                <a:latin typeface="Calibri" pitchFamily="34" charset="0"/>
-                <a:ea typeface="Calibri" pitchFamily="34" charset="-122"/>
-                <a:cs typeface="Calibri" pitchFamily="34" charset="-120"/>
-              </a:rPr>
-              <a:t>NetBox</a:t>
-            </a:r>
-            <a:endParaRPr lang="en-US" sz="800" dirty="0"/>
-          </a:p>
-        </p:txBody>
-      </p:sp>
-      <p:sp>
-        <p:nvSpPr>
-          <p:cNvPr id="60" name="VMware vSphere (Release 2)"/>
-          <p:cNvSpPr/>
-          <p:nvPr/>
-        </p:nvSpPr>
-        <p:spPr>
-          <a:xfrm>
-            <a:off x="5907024" y="2651760"/>
-            <a:ext cx="868680" cy="128016"/>
+              <a:rPr lang="en-US" sz="850" dirty="0">
+                <a:solidFill>
+                  <a:srgbClr val="0F3F38"/>
+                </a:solidFill>
+                <a:latin typeface="Calibri" pitchFamily="34" charset="0"/>
+                <a:ea typeface="Calibri" pitchFamily="34" charset="-122"/>
+                <a:cs typeface="Calibri" pitchFamily="34" charset="-120"/>
+              </a:rPr>
+              <a:t>VMware vSphere</a:t>
+            </a:r>
+            <a:endParaRPr lang="en-US" sz="850" dirty="0"/>
+          </a:p>
+        </p:txBody>
+      </p:sp>
+      <p:sp>
+        <p:nvSpPr>
+          <p:cNvPr id="60" name="Azure Resource Graph (Release 2)"/>
+          <p:cNvSpPr/>
+          <p:nvPr/>
+        </p:nvSpPr>
+        <p:spPr>
+          <a:xfrm>
+            <a:off x="5907024" y="2590495"/>
+            <a:ext cx="868680" cy="137160"/>
           </a:xfrm>
           <a:prstGeom prst="roundRect">
             <a:avLst>
-              <a:gd name="adj" fmla="val 21429"/>
+              <a:gd name="adj" fmla="val 20000"/>
             </a:avLst>
           </a:prstGeom>
           <a:solidFill>
@@ -3124,7 +3124,7 @@
               <a:buNone/>
             </a:pPr>
             <a:r>
-              <a:rPr lang="en-US" sz="800" dirty="0">
+              <a:rPr lang="en-US" sz="700" dirty="0">
                 <a:solidFill>
                   <a:srgbClr val="0F3F38"/>
                 </a:solidFill>
@@ -3132,26 +3132,26 @@
                 <a:ea typeface="Calibri" pitchFamily="34" charset="-122"/>
                 <a:cs typeface="Calibri" pitchFamily="34" charset="-120"/>
               </a:rPr>
-              <a:t>VMware vSphere</a:t>
-            </a:r>
-            <a:endParaRPr lang="en-US" sz="800" dirty="0"/>
-          </a:p>
-        </p:txBody>
-      </p:sp>
-      <p:sp>
-        <p:nvSpPr>
-          <p:cNvPr id="61" name="Azure Resource Graph (Release 2)"/>
-          <p:cNvSpPr/>
-          <p:nvPr/>
-        </p:nvSpPr>
-        <p:spPr>
-          <a:xfrm>
-            <a:off x="5907024" y="2798064"/>
-            <a:ext cx="868680" cy="128016"/>
+              <a:t>Azure Resource Graph</a:t>
+            </a:r>
+            <a:endParaRPr lang="en-US" sz="700" dirty="0"/>
+          </a:p>
+        </p:txBody>
+      </p:sp>
+      <p:sp>
+        <p:nvSpPr>
+          <p:cNvPr id="61" name="HP (Release 2)"/>
+          <p:cNvSpPr/>
+          <p:nvPr/>
+        </p:nvSpPr>
+        <p:spPr>
+          <a:xfrm>
+            <a:off x="5907024" y="2747772"/>
+            <a:ext cx="868680" cy="137160"/>
           </a:xfrm>
           <a:prstGeom prst="roundRect">
             <a:avLst>
-              <a:gd name="adj" fmla="val 21429"/>
+              <a:gd name="adj" fmla="val 20000"/>
             </a:avLst>
           </a:prstGeom>
           <a:solidFill>
@@ -3171,7 +3171,7 @@
               <a:buNone/>
             </a:pPr>
             <a:r>
-              <a:rPr lang="en-US" sz="700" dirty="0">
+              <a:rPr lang="en-US" sz="850" dirty="0">
                 <a:solidFill>
                   <a:srgbClr val="0F3F38"/>
                 </a:solidFill>
@@ -3179,35 +3179,36 @@
                 <a:ea typeface="Calibri" pitchFamily="34" charset="-122"/>
                 <a:cs typeface="Calibri" pitchFamily="34" charset="-120"/>
               </a:rPr>
-              <a:t>Azure Resource Graph</a:t>
-            </a:r>
-            <a:endParaRPr lang="en-US" sz="700" dirty="0"/>
-          </a:p>
-        </p:txBody>
-      </p:sp>
-      <p:sp>
-        <p:nvSpPr>
-          <p:cNvPr id="62" name="HP (Release 2)"/>
-          <p:cNvSpPr/>
-          <p:nvPr/>
-        </p:nvSpPr>
-        <p:spPr>
-          <a:xfrm>
-            <a:off x="5907024" y="2944368"/>
-            <a:ext cx="868680" cy="128016"/>
+              <a:t>HP</a:t>
+            </a:r>
+            <a:endParaRPr lang="en-US" sz="850" dirty="0"/>
+          </a:p>
+        </p:txBody>
+      </p:sp>
+      <p:sp>
+        <p:nvSpPr>
+          <p:cNvPr id="62" name="NetBox (TBD)"/>
+          <p:cNvSpPr/>
+          <p:nvPr/>
+        </p:nvSpPr>
+        <p:spPr>
+          <a:xfrm>
+            <a:off x="10808208" y="2590495"/>
+            <a:ext cx="905256" cy="137160"/>
           </a:xfrm>
           <a:prstGeom prst="roundRect">
             <a:avLst>
-              <a:gd name="adj" fmla="val 21429"/>
+              <a:gd name="adj" fmla="val 20000"/>
             </a:avLst>
           </a:prstGeom>
           <a:solidFill>
-            <a:srgbClr val="A8DCD1"/>
-          </a:solidFill>
-          <a:ln w="6350">
-            <a:solidFill>
-              <a:srgbClr val="A8DCD1"/>
-            </a:solidFill>
+            <a:srgbClr val="FFFFFF"/>
+          </a:solidFill>
+          <a:ln w="9525">
+            <a:solidFill>
+              <a:srgbClr val="6B7280"/>
+            </a:solidFill>
+            <a:prstDash val="dash"/>
           </a:ln>
         </p:spPr>
         <p:txBody>
@@ -3218,17 +3219,17 @@
               <a:buNone/>
             </a:pPr>
             <a:r>
-              <a:rPr lang="en-US" sz="800" dirty="0">
-                <a:solidFill>
-                  <a:srgbClr val="0F3F38"/>
-                </a:solidFill>
-                <a:latin typeface="Calibri" pitchFamily="34" charset="0"/>
-                <a:ea typeface="Calibri" pitchFamily="34" charset="-122"/>
-                <a:cs typeface="Calibri" pitchFamily="34" charset="-120"/>
-              </a:rPr>
-              <a:t>HP</a:t>
-            </a:r>
-            <a:endParaRPr lang="en-US" sz="800" dirty="0"/>
+              <a:rPr lang="en-US" sz="850" dirty="0">
+                <a:solidFill>
+                  <a:srgbClr val="374151"/>
+                </a:solidFill>
+                <a:latin typeface="Calibri" pitchFamily="34" charset="0"/>
+                <a:ea typeface="Calibri" pitchFamily="34" charset="-122"/>
+                <a:cs typeface="Calibri" pitchFamily="34" charset="-120"/>
+              </a:rPr>
+              <a:t>NetBox</a:t>
+            </a:r>
+            <a:endParaRPr lang="en-US" sz="850" dirty="0"/>
           </a:p>
         </p:txBody>
       </p:sp>
@@ -3240,8 +3241,8 @@
         </p:nvSpPr>
         <p:spPr>
           <a:xfrm>
-            <a:off x="320040" y="3182112"/>
-            <a:ext cx="10259568" cy="640080"/>
+            <a:off x="320040" y="2926080"/>
+            <a:ext cx="10259568" cy="534010"/>
           </a:xfrm>
           <a:prstGeom prst="rect">
             <a:avLst/>
@@ -3265,7 +3266,7 @@
         </p:nvSpPr>
         <p:spPr>
           <a:xfrm>
-            <a:off x="10652760" y="3822192"/>
+            <a:off x="10652760" y="3460090"/>
             <a:ext cx="1216152" cy="0"/>
           </a:xfrm>
           <a:prstGeom prst="line">
@@ -3296,7 +3297,7 @@
         </p:blipFill>
         <p:spPr>
           <a:xfrm>
-            <a:off x="429768" y="3383280"/>
+            <a:off x="429768" y="3074213"/>
             <a:ext cx="237744" cy="237744"/>
           </a:xfrm>
           <a:prstGeom prst="rect">
@@ -3312,8 +3313,8 @@
         </p:nvSpPr>
         <p:spPr>
           <a:xfrm>
-            <a:off x="777240" y="3182112"/>
-            <a:ext cx="1307592" cy="640080"/>
+            <a:off x="777240" y="2926080"/>
+            <a:ext cx="1307592" cy="534010"/>
           </a:xfrm>
           <a:prstGeom prst="rect">
             <a:avLst/>
@@ -3368,12 +3369,12 @@
         </p:nvSpPr>
         <p:spPr>
           <a:xfrm>
-            <a:off x="5907024" y="3291840"/>
-            <a:ext cx="868680" cy="128016"/>
+            <a:off x="5907024" y="2967228"/>
+            <a:ext cx="868680" cy="137160"/>
           </a:xfrm>
           <a:prstGeom prst="roundRect">
             <a:avLst>
-              <a:gd name="adj" fmla="val 21429"/>
+              <a:gd name="adj" fmla="val 20000"/>
             </a:avLst>
           </a:prstGeom>
           <a:solidFill>
@@ -3393,7 +3394,7 @@
               <a:buNone/>
             </a:pPr>
             <a:r>
-              <a:rPr lang="en-US" sz="800" dirty="0">
+              <a:rPr lang="en-US" sz="850" dirty="0">
                 <a:solidFill>
                   <a:srgbClr val="0F3F38"/>
                 </a:solidFill>
@@ -3403,7 +3404,7 @@
               </a:rPr>
               <a:t>Azure Monitoring</a:t>
             </a:r>
-            <a:endParaRPr lang="en-US" sz="800" dirty="0"/>
+            <a:endParaRPr lang="en-US" sz="850" dirty="0"/>
           </a:p>
         </p:txBody>
       </p:sp>
@@ -3415,12 +3416,12 @@
         </p:nvSpPr>
         <p:spPr>
           <a:xfrm>
-            <a:off x="5907024" y="3438144"/>
-            <a:ext cx="868680" cy="128016"/>
+            <a:off x="5907024" y="3124505"/>
+            <a:ext cx="868680" cy="137160"/>
           </a:xfrm>
           <a:prstGeom prst="roundRect">
             <a:avLst>
-              <a:gd name="adj" fmla="val 21429"/>
+              <a:gd name="adj" fmla="val 20000"/>
             </a:avLst>
           </a:prstGeom>
           <a:solidFill>
@@ -3440,7 +3441,7 @@
               <a:buNone/>
             </a:pPr>
             <a:r>
-              <a:rPr lang="en-US" sz="800" dirty="0">
+              <a:rPr lang="en-US" sz="850" dirty="0">
                 <a:solidFill>
                   <a:srgbClr val="0F3F38"/>
                 </a:solidFill>
@@ -3450,7 +3451,7 @@
               </a:rPr>
               <a:t>PRTG</a:t>
             </a:r>
-            <a:endParaRPr lang="en-US" sz="800" dirty="0"/>
+            <a:endParaRPr lang="en-US" sz="850" dirty="0"/>
           </a:p>
         </p:txBody>
       </p:sp>
@@ -3462,12 +3463,12 @@
         </p:nvSpPr>
         <p:spPr>
           <a:xfrm>
-            <a:off x="5907024" y="3584448"/>
-            <a:ext cx="868680" cy="128016"/>
+            <a:off x="5907024" y="3281782"/>
+            <a:ext cx="868680" cy="137160"/>
           </a:xfrm>
           <a:prstGeom prst="roundRect">
             <a:avLst>
-              <a:gd name="adj" fmla="val 21429"/>
+              <a:gd name="adj" fmla="val 20000"/>
             </a:avLst>
           </a:prstGeom>
           <a:solidFill>
@@ -3487,7 +3488,7 @@
               <a:buNone/>
             </a:pPr>
             <a:r>
-              <a:rPr lang="en-US" sz="800" dirty="0">
+              <a:rPr lang="en-US" sz="850" dirty="0">
                 <a:solidFill>
                   <a:srgbClr val="0F3F38"/>
                 </a:solidFill>
@@ -3497,24 +3498,24 @@
               </a:rPr>
               <a:t>CrowdStrike</a:t>
             </a:r>
-            <a:endParaRPr lang="en-US" sz="800" dirty="0"/>
-          </a:p>
-        </p:txBody>
-      </p:sp>
-      <p:sp>
-        <p:nvSpPr>
-          <p:cNvPr id="70" name="Tenable (Release 3)"/>
-          <p:cNvSpPr/>
-          <p:nvPr/>
-        </p:nvSpPr>
-        <p:spPr>
-          <a:xfrm>
-            <a:off x="8732520" y="3218688"/>
-            <a:ext cx="868680" cy="128016"/>
+            <a:endParaRPr lang="en-US" sz="850" dirty="0"/>
+          </a:p>
+        </p:txBody>
+      </p:sp>
+      <p:sp>
+        <p:nvSpPr>
+          <p:cNvPr id="70" name="LogRhythm (Release 3)"/>
+          <p:cNvSpPr/>
+          <p:nvPr/>
+        </p:nvSpPr>
+        <p:spPr>
+          <a:xfrm>
+            <a:off x="8732520" y="2967228"/>
+            <a:ext cx="868680" cy="137160"/>
           </a:xfrm>
           <a:prstGeom prst="roundRect">
             <a:avLst>
-              <a:gd name="adj" fmla="val 21429"/>
+              <a:gd name="adj" fmla="val 20000"/>
             </a:avLst>
           </a:prstGeom>
           <a:solidFill>
@@ -3534,7 +3535,7 @@
               <a:buNone/>
             </a:pPr>
             <a:r>
-              <a:rPr lang="en-US" sz="800" dirty="0">
+              <a:rPr lang="en-US" sz="850" dirty="0">
                 <a:solidFill>
                   <a:srgbClr val="2A1B5E"/>
                 </a:solidFill>
@@ -3542,26 +3543,26 @@
                 <a:ea typeface="Calibri" pitchFamily="34" charset="-122"/>
                 <a:cs typeface="Calibri" pitchFamily="34" charset="-120"/>
               </a:rPr>
-              <a:t>Tenable</a:t>
-            </a:r>
-            <a:endParaRPr lang="en-US" sz="800" dirty="0"/>
-          </a:p>
-        </p:txBody>
-      </p:sp>
-      <p:sp>
-        <p:nvSpPr>
-          <p:cNvPr id="71" name="LogRhythm (Release 3)"/>
-          <p:cNvSpPr/>
-          <p:nvPr/>
-        </p:nvSpPr>
-        <p:spPr>
-          <a:xfrm>
-            <a:off x="8732520" y="3364992"/>
-            <a:ext cx="868680" cy="128016"/>
+              <a:t>LogRhythm</a:t>
+            </a:r>
+            <a:endParaRPr lang="en-US" sz="850" dirty="0"/>
+          </a:p>
+        </p:txBody>
+      </p:sp>
+      <p:sp>
+        <p:nvSpPr>
+          <p:cNvPr id="71" name="Seamless SOC (Release 3)"/>
+          <p:cNvSpPr/>
+          <p:nvPr/>
+        </p:nvSpPr>
+        <p:spPr>
+          <a:xfrm>
+            <a:off x="8732520" y="3124505"/>
+            <a:ext cx="868680" cy="137160"/>
           </a:xfrm>
           <a:prstGeom prst="roundRect">
             <a:avLst>
-              <a:gd name="adj" fmla="val 21429"/>
+              <a:gd name="adj" fmla="val 20000"/>
             </a:avLst>
           </a:prstGeom>
           <a:solidFill>
@@ -3581,7 +3582,7 @@
               <a:buNone/>
             </a:pPr>
             <a:r>
-              <a:rPr lang="en-US" sz="800" dirty="0">
+              <a:rPr lang="en-US" sz="850" dirty="0">
                 <a:solidFill>
                   <a:srgbClr val="2A1B5E"/>
                 </a:solidFill>
@@ -3589,26 +3590,26 @@
                 <a:ea typeface="Calibri" pitchFamily="34" charset="-122"/>
                 <a:cs typeface="Calibri" pitchFamily="34" charset="-120"/>
               </a:rPr>
-              <a:t>LogRhythm</a:t>
-            </a:r>
-            <a:endParaRPr lang="en-US" sz="800" dirty="0"/>
-          </a:p>
-        </p:txBody>
-      </p:sp>
-      <p:sp>
-        <p:nvSpPr>
-          <p:cNvPr id="72" name="Seamless SOC (Release 3)"/>
-          <p:cNvSpPr/>
-          <p:nvPr/>
-        </p:nvSpPr>
-        <p:spPr>
-          <a:xfrm>
-            <a:off x="8732520" y="3511296"/>
-            <a:ext cx="868680" cy="128016"/>
+              <a:t>Seamless SOC</a:t>
+            </a:r>
+            <a:endParaRPr lang="en-US" sz="850" dirty="0"/>
+          </a:p>
+        </p:txBody>
+      </p:sp>
+      <p:sp>
+        <p:nvSpPr>
+          <p:cNvPr id="72" name="Medigate (Release 3)"/>
+          <p:cNvSpPr/>
+          <p:nvPr/>
+        </p:nvSpPr>
+        <p:spPr>
+          <a:xfrm>
+            <a:off x="8732520" y="3281782"/>
+            <a:ext cx="868680" cy="137160"/>
           </a:xfrm>
           <a:prstGeom prst="roundRect">
             <a:avLst>
-              <a:gd name="adj" fmla="val 21429"/>
+              <a:gd name="adj" fmla="val 20000"/>
             </a:avLst>
           </a:prstGeom>
           <a:solidFill>
@@ -3628,7 +3629,7 @@
               <a:buNone/>
             </a:pPr>
             <a:r>
-              <a:rPr lang="en-US" sz="800" dirty="0">
+              <a:rPr lang="en-US" sz="850" dirty="0">
                 <a:solidFill>
                   <a:srgbClr val="2A1B5E"/>
                 </a:solidFill>
@@ -3636,35 +3637,36 @@
                 <a:ea typeface="Calibri" pitchFamily="34" charset="-122"/>
                 <a:cs typeface="Calibri" pitchFamily="34" charset="-120"/>
               </a:rPr>
-              <a:t>Seamless SOC</a:t>
-            </a:r>
-            <a:endParaRPr lang="en-US" sz="800" dirty="0"/>
-          </a:p>
-        </p:txBody>
-      </p:sp>
-      <p:sp>
-        <p:nvSpPr>
-          <p:cNvPr id="73" name="Medigate (Release 3)"/>
-          <p:cNvSpPr/>
-          <p:nvPr/>
-        </p:nvSpPr>
-        <p:spPr>
-          <a:xfrm>
-            <a:off x="8732520" y="3657600"/>
-            <a:ext cx="868680" cy="128016"/>
+              <a:t>Medigate</a:t>
+            </a:r>
+            <a:endParaRPr lang="en-US" sz="850" dirty="0"/>
+          </a:p>
+        </p:txBody>
+      </p:sp>
+      <p:sp>
+        <p:nvSpPr>
+          <p:cNvPr id="73" name="Tenable (TBD)"/>
+          <p:cNvSpPr/>
+          <p:nvPr/>
+        </p:nvSpPr>
+        <p:spPr>
+          <a:xfrm>
+            <a:off x="10808208" y="3124505"/>
+            <a:ext cx="905256" cy="137160"/>
           </a:xfrm>
           <a:prstGeom prst="roundRect">
             <a:avLst>
-              <a:gd name="adj" fmla="val 21429"/>
+              <a:gd name="adj" fmla="val 20000"/>
             </a:avLst>
           </a:prstGeom>
           <a:solidFill>
-            <a:srgbClr val="C9B9F2"/>
-          </a:solidFill>
-          <a:ln w="6350">
-            <a:solidFill>
-              <a:srgbClr val="C9B9F2"/>
-            </a:solidFill>
+            <a:srgbClr val="FFFFFF"/>
+          </a:solidFill>
+          <a:ln w="9525">
+            <a:solidFill>
+              <a:srgbClr val="6B7280"/>
+            </a:solidFill>
+            <a:prstDash val="dash"/>
           </a:ln>
         </p:spPr>
         <p:txBody>
@@ -3675,17 +3677,17 @@
               <a:buNone/>
             </a:pPr>
             <a:r>
-              <a:rPr lang="en-US" sz="800" dirty="0">
-                <a:solidFill>
-                  <a:srgbClr val="2A1B5E"/>
-                </a:solidFill>
-                <a:latin typeface="Calibri" pitchFamily="34" charset="0"/>
-                <a:ea typeface="Calibri" pitchFamily="34" charset="-122"/>
-                <a:cs typeface="Calibri" pitchFamily="34" charset="-120"/>
-              </a:rPr>
-              <a:t>Medigate</a:t>
-            </a:r>
-            <a:endParaRPr lang="en-US" sz="800" dirty="0"/>
+              <a:rPr lang="en-US" sz="850" dirty="0">
+                <a:solidFill>
+                  <a:srgbClr val="374151"/>
+                </a:solidFill>
+                <a:latin typeface="Calibri" pitchFamily="34" charset="0"/>
+                <a:ea typeface="Calibri" pitchFamily="34" charset="-122"/>
+                <a:cs typeface="Calibri" pitchFamily="34" charset="-120"/>
+              </a:rPr>
+              <a:t>Tenable</a:t>
+            </a:r>
+            <a:endParaRPr lang="en-US" sz="850" dirty="0"/>
           </a:p>
         </p:txBody>
       </p:sp>
@@ -3697,8 +3699,8 @@
         </p:nvSpPr>
         <p:spPr>
           <a:xfrm>
-            <a:off x="320040" y="3822192"/>
-            <a:ext cx="10259568" cy="347472"/>
+            <a:off x="320040" y="3460090"/>
+            <a:ext cx="10259568" cy="376733"/>
           </a:xfrm>
           <a:prstGeom prst="rect">
             <a:avLst/>
@@ -3722,7 +3724,7 @@
         </p:nvSpPr>
         <p:spPr>
           <a:xfrm>
-            <a:off x="10652760" y="4169664"/>
+            <a:off x="10652760" y="3836822"/>
             <a:ext cx="1216152" cy="0"/>
           </a:xfrm>
           <a:prstGeom prst="line">
@@ -3753,7 +3755,7 @@
         </p:blipFill>
         <p:spPr>
           <a:xfrm>
-            <a:off x="429768" y="3877056"/>
+            <a:off x="429768" y="3529584"/>
             <a:ext cx="237744" cy="237744"/>
           </a:xfrm>
           <a:prstGeom prst="rect">
@@ -3769,8 +3771,8 @@
         </p:nvSpPr>
         <p:spPr>
           <a:xfrm>
-            <a:off x="777240" y="3822192"/>
-            <a:ext cx="1307592" cy="347472"/>
+            <a:off x="777240" y="3460090"/>
+            <a:ext cx="1307592" cy="376733"/>
           </a:xfrm>
           <a:prstGeom prst="rect">
             <a:avLst/>
@@ -3825,12 +3827,12 @@
         </p:nvSpPr>
         <p:spPr>
           <a:xfrm>
-            <a:off x="5907024" y="3858768"/>
-            <a:ext cx="868680" cy="128016"/>
+            <a:off x="5907024" y="3501238"/>
+            <a:ext cx="868680" cy="137160"/>
           </a:xfrm>
           <a:prstGeom prst="roundRect">
             <a:avLst>
-              <a:gd name="adj" fmla="val 21429"/>
+              <a:gd name="adj" fmla="val 20000"/>
             </a:avLst>
           </a:prstGeom>
           <a:solidFill>
@@ -3850,7 +3852,7 @@
               <a:buNone/>
             </a:pPr>
             <a:r>
-              <a:rPr lang="en-US" sz="800" dirty="0">
+              <a:rPr lang="en-US" sz="850" dirty="0">
                 <a:solidFill>
                   <a:srgbClr val="0F3F38"/>
                 </a:solidFill>
@@ -3860,7 +3862,7 @@
               </a:rPr>
               <a:t>Azure DevOps</a:t>
             </a:r>
-            <a:endParaRPr lang="en-US" sz="800" dirty="0"/>
+            <a:endParaRPr lang="en-US" sz="850" dirty="0"/>
           </a:p>
         </p:txBody>
       </p:sp>
@@ -3872,12 +3874,12 @@
         </p:nvSpPr>
         <p:spPr>
           <a:xfrm>
-            <a:off x="5907024" y="4005072"/>
-            <a:ext cx="868680" cy="128016"/>
+            <a:off x="5907024" y="3658514"/>
+            <a:ext cx="868680" cy="137160"/>
           </a:xfrm>
           <a:prstGeom prst="roundRect">
             <a:avLst>
-              <a:gd name="adj" fmla="val 21429"/>
+              <a:gd name="adj" fmla="val 20000"/>
             </a:avLst>
           </a:prstGeom>
           <a:solidFill>
@@ -3919,12 +3921,12 @@
         </p:nvSpPr>
         <p:spPr>
           <a:xfrm>
-            <a:off x="10808208" y="3858768"/>
-            <a:ext cx="905256" cy="128016"/>
+            <a:off x="10808208" y="3501238"/>
+            <a:ext cx="905256" cy="137160"/>
           </a:xfrm>
           <a:prstGeom prst="roundRect">
             <a:avLst>
-              <a:gd name="adj" fmla="val 21429"/>
+              <a:gd name="adj" fmla="val 20000"/>
             </a:avLst>
           </a:prstGeom>
           <a:solidFill>
@@ -3945,7 +3947,7 @@
               <a:buNone/>
             </a:pPr>
             <a:r>
-              <a:rPr lang="en-US" sz="800" dirty="0">
+              <a:rPr lang="en-US" sz="850" dirty="0">
                 <a:solidFill>
                   <a:srgbClr val="374151"/>
                 </a:solidFill>
@@ -3955,7 +3957,7 @@
               </a:rPr>
               <a:t>Copilot</a:t>
             </a:r>
-            <a:endParaRPr lang="en-US" sz="800" dirty="0"/>
+            <a:endParaRPr lang="en-US" sz="850" dirty="0"/>
           </a:p>
         </p:txBody>
       </p:sp>
@@ -3967,12 +3969,12 @@
         </p:nvSpPr>
         <p:spPr>
           <a:xfrm>
-            <a:off x="10808208" y="4005072"/>
-            <a:ext cx="905256" cy="128016"/>
+            <a:off x="10808208" y="3658514"/>
+            <a:ext cx="905256" cy="137160"/>
           </a:xfrm>
           <a:prstGeom prst="roundRect">
             <a:avLst>
-              <a:gd name="adj" fmla="val 21429"/>
+              <a:gd name="adj" fmla="val 20000"/>
             </a:avLst>
           </a:prstGeom>
           <a:solidFill>
@@ -3993,7 +3995,7 @@
               <a:buNone/>
             </a:pPr>
             <a:r>
-              <a:rPr lang="en-US" sz="800" dirty="0">
+              <a:rPr lang="en-US" sz="850" dirty="0">
                 <a:solidFill>
                   <a:srgbClr val="374151"/>
                 </a:solidFill>
@@ -4003,7 +4005,7 @@
               </a:rPr>
               <a:t>Azure OpenAI</a:t>
             </a:r>
-            <a:endParaRPr lang="en-US" sz="800" dirty="0"/>
+            <a:endParaRPr lang="en-US" sz="850" dirty="0"/>
           </a:p>
         </p:txBody>
       </p:sp>
@@ -4015,8 +4017,8 @@
         </p:nvSpPr>
         <p:spPr>
           <a:xfrm>
-            <a:off x="320040" y="4169664"/>
-            <a:ext cx="10259568" cy="640080"/>
+            <a:off x="320040" y="3836822"/>
+            <a:ext cx="10259568" cy="691286"/>
           </a:xfrm>
           <a:prstGeom prst="rect">
             <a:avLst/>
@@ -4040,7 +4042,7 @@
         </p:nvSpPr>
         <p:spPr>
           <a:xfrm>
-            <a:off x="10652760" y="4809744"/>
+            <a:off x="10652760" y="4528109"/>
             <a:ext cx="1216152" cy="0"/>
           </a:xfrm>
           <a:prstGeom prst="line">
@@ -4071,7 +4073,7 @@
         </p:blipFill>
         <p:spPr>
           <a:xfrm>
-            <a:off x="429768" y="4370832"/>
+            <a:off x="429768" y="4063594"/>
             <a:ext cx="237744" cy="237744"/>
           </a:xfrm>
           <a:prstGeom prst="rect">
@@ -4087,8 +4089,8 @@
         </p:nvSpPr>
         <p:spPr>
           <a:xfrm>
-            <a:off x="777240" y="4169664"/>
-            <a:ext cx="1307592" cy="640080"/>
+            <a:off x="777240" y="3836822"/>
+            <a:ext cx="1307592" cy="691286"/>
           </a:xfrm>
           <a:prstGeom prst="rect">
             <a:avLst/>
@@ -4137,26 +4139,26 @@
       </p:sp>
       <p:sp>
         <p:nvSpPr>
-          <p:cNvPr id="86" name="NTT CMDB (Release 1)"/>
-          <p:cNvSpPr/>
-          <p:nvPr/>
-        </p:nvSpPr>
-        <p:spPr>
-          <a:xfrm>
-            <a:off x="4023360" y="4425696"/>
-            <a:ext cx="868680" cy="128016"/>
+          <p:cNvPr id="86" name="NTT CMDB (Release 2)"/>
+          <p:cNvSpPr/>
+          <p:nvPr/>
+        </p:nvSpPr>
+        <p:spPr>
+          <a:xfrm>
+            <a:off x="4965192" y="4113886"/>
+            <a:ext cx="868680" cy="137160"/>
           </a:xfrm>
           <a:prstGeom prst="roundRect">
             <a:avLst>
-              <a:gd name="adj" fmla="val 21429"/>
+              <a:gd name="adj" fmla="val 20000"/>
             </a:avLst>
           </a:prstGeom>
           <a:solidFill>
-            <a:srgbClr val="A9CBF2"/>
+            <a:srgbClr val="A8DCD1"/>
           </a:solidFill>
           <a:ln w="6350">
             <a:solidFill>
-              <a:srgbClr val="A9CBF2"/>
+              <a:srgbClr val="A8DCD1"/>
             </a:solidFill>
           </a:ln>
         </p:spPr>
@@ -4168,9 +4170,9 @@
               <a:buNone/>
             </a:pPr>
             <a:r>
-              <a:rPr lang="en-US" sz="800" dirty="0">
-                <a:solidFill>
-                  <a:srgbClr val="14285A"/>
+              <a:rPr lang="en-US" sz="850" dirty="0">
+                <a:solidFill>
+                  <a:srgbClr val="0F3F38"/>
                 </a:solidFill>
                 <a:latin typeface="Calibri" pitchFamily="34" charset="0"/>
                 <a:ea typeface="Calibri" pitchFamily="34" charset="-122"/>
@@ -4178,7 +4180,7 @@
               </a:rPr>
               <a:t>NTT CMDB</a:t>
             </a:r>
-            <a:endParaRPr lang="en-US" sz="800" dirty="0"/>
+            <a:endParaRPr lang="en-US" sz="850" dirty="0"/>
           </a:p>
         </p:txBody>
       </p:sp>
@@ -4190,12 +4192,12 @@
         </p:nvSpPr>
         <p:spPr>
           <a:xfrm>
-            <a:off x="8732520" y="4206240"/>
-            <a:ext cx="868680" cy="128016"/>
+            <a:off x="8732520" y="3877970"/>
+            <a:ext cx="868680" cy="137160"/>
           </a:xfrm>
           <a:prstGeom prst="roundRect">
             <a:avLst>
-              <a:gd name="adj" fmla="val 21429"/>
+              <a:gd name="adj" fmla="val 20000"/>
             </a:avLst>
           </a:prstGeom>
           <a:solidFill>
@@ -4215,7 +4217,7 @@
               <a:buNone/>
             </a:pPr>
             <a:r>
-              <a:rPr lang="en-US" sz="800" dirty="0">
+              <a:rPr lang="en-US" sz="850" dirty="0">
                 <a:solidFill>
                   <a:srgbClr val="2A1B5E"/>
                 </a:solidFill>
@@ -4225,7 +4227,7 @@
               </a:rPr>
               <a:t>NTT</a:t>
             </a:r>
-            <a:endParaRPr lang="en-US" sz="800" dirty="0"/>
+            <a:endParaRPr lang="en-US" sz="850" dirty="0"/>
           </a:p>
         </p:txBody>
       </p:sp>
@@ -4237,12 +4239,12 @@
         </p:nvSpPr>
         <p:spPr>
           <a:xfrm>
-            <a:off x="8732520" y="4352544"/>
-            <a:ext cx="868680" cy="128016"/>
+            <a:off x="8732520" y="4035247"/>
+            <a:ext cx="868680" cy="137160"/>
           </a:xfrm>
           <a:prstGeom prst="roundRect">
             <a:avLst>
-              <a:gd name="adj" fmla="val 21429"/>
+              <a:gd name="adj" fmla="val 20000"/>
             </a:avLst>
           </a:prstGeom>
           <a:solidFill>
@@ -4262,7 +4264,7 @@
               <a:buNone/>
             </a:pPr>
             <a:r>
-              <a:rPr lang="en-US" sz="800" dirty="0">
+              <a:rPr lang="en-US" sz="850" dirty="0">
                 <a:solidFill>
                   <a:srgbClr val="2A1B5E"/>
                 </a:solidFill>
@@ -4272,7 +4274,7 @@
               </a:rPr>
               <a:t>Optus</a:t>
             </a:r>
-            <a:endParaRPr lang="en-US" sz="800" dirty="0"/>
+            <a:endParaRPr lang="en-US" sz="850" dirty="0"/>
           </a:p>
         </p:txBody>
       </p:sp>
@@ -4284,12 +4286,12 @@
         </p:nvSpPr>
         <p:spPr>
           <a:xfrm>
-            <a:off x="8732520" y="4498848"/>
-            <a:ext cx="868680" cy="128016"/>
+            <a:off x="8732520" y="4192524"/>
+            <a:ext cx="868680" cy="137160"/>
           </a:xfrm>
           <a:prstGeom prst="roundRect">
             <a:avLst>
-              <a:gd name="adj" fmla="val 21429"/>
+              <a:gd name="adj" fmla="val 20000"/>
             </a:avLst>
           </a:prstGeom>
           <a:solidFill>
@@ -4309,7 +4311,7 @@
               <a:buNone/>
             </a:pPr>
             <a:r>
-              <a:rPr lang="en-US" sz="800" dirty="0">
+              <a:rPr lang="en-US" sz="850" dirty="0">
                 <a:solidFill>
                   <a:srgbClr val="2A1B5E"/>
                 </a:solidFill>
@@ -4319,7 +4321,7 @@
               </a:rPr>
               <a:t>Cognizant</a:t>
             </a:r>
-            <a:endParaRPr lang="en-US" sz="800" dirty="0"/>
+            <a:endParaRPr lang="en-US" sz="850" dirty="0"/>
           </a:p>
         </p:txBody>
       </p:sp>
@@ -4331,12 +4333,12 @@
         </p:nvSpPr>
         <p:spPr>
           <a:xfrm>
-            <a:off x="8732520" y="4645152"/>
-            <a:ext cx="868680" cy="128016"/>
+            <a:off x="8732520" y="4349801"/>
+            <a:ext cx="868680" cy="137160"/>
           </a:xfrm>
           <a:prstGeom prst="roundRect">
             <a:avLst>
-              <a:gd name="adj" fmla="val 21429"/>
+              <a:gd name="adj" fmla="val 20000"/>
             </a:avLst>
           </a:prstGeom>
           <a:solidFill>
@@ -4356,7 +4358,7 @@
               <a:buNone/>
             </a:pPr>
             <a:r>
-              <a:rPr lang="en-US" sz="800" dirty="0">
+              <a:rPr lang="en-US" sz="850" dirty="0">
                 <a:solidFill>
                   <a:srgbClr val="2A1B5E"/>
                 </a:solidFill>
@@ -4366,7 +4368,7 @@
               </a:rPr>
               <a:t>Accenture</a:t>
             </a:r>
-            <a:endParaRPr lang="en-US" sz="800" dirty="0"/>
+            <a:endParaRPr lang="en-US" sz="850" dirty="0"/>
           </a:p>
         </p:txBody>
       </p:sp>
@@ -4378,12 +4380,12 @@
         </p:nvSpPr>
         <p:spPr>
           <a:xfrm>
-            <a:off x="10808208" y="4352544"/>
-            <a:ext cx="905256" cy="128016"/>
+            <a:off x="10808208" y="4035247"/>
+            <a:ext cx="905256" cy="137160"/>
           </a:xfrm>
           <a:prstGeom prst="roundRect">
             <a:avLst>
-              <a:gd name="adj" fmla="val 21429"/>
+              <a:gd name="adj" fmla="val 20000"/>
             </a:avLst>
           </a:prstGeom>
           <a:solidFill>
@@ -4404,7 +4406,7 @@
               <a:buNone/>
             </a:pPr>
             <a:r>
-              <a:rPr lang="en-US" sz="800" dirty="0">
+              <a:rPr lang="en-US" sz="850" dirty="0">
                 <a:solidFill>
                   <a:srgbClr val="374151"/>
                 </a:solidFill>
@@ -4414,7 +4416,7 @@
               </a:rPr>
               <a:t>Ready Contracts</a:t>
             </a:r>
-            <a:endParaRPr lang="en-US" sz="800" dirty="0"/>
+            <a:endParaRPr lang="en-US" sz="850" dirty="0"/>
           </a:p>
         </p:txBody>
       </p:sp>
@@ -4426,12 +4428,12 @@
         </p:nvSpPr>
         <p:spPr>
           <a:xfrm>
-            <a:off x="10808208" y="4498848"/>
-            <a:ext cx="905256" cy="128016"/>
+            <a:off x="10808208" y="4192524"/>
+            <a:ext cx="905256" cy="137160"/>
           </a:xfrm>
           <a:prstGeom prst="roundRect">
             <a:avLst>
-              <a:gd name="adj" fmla="val 21429"/>
+              <a:gd name="adj" fmla="val 20000"/>
             </a:avLst>
           </a:prstGeom>
           <a:solidFill>
@@ -4452,7 +4454,7 @@
               <a:buNone/>
             </a:pPr>
             <a:r>
-              <a:rPr lang="en-US" sz="800" dirty="0">
+              <a:rPr lang="en-US" sz="850" dirty="0">
                 <a:solidFill>
                   <a:srgbClr val="374151"/>
                 </a:solidFill>
@@ -4462,7 +4464,7 @@
               </a:rPr>
               <a:t>Rhapsody</a:t>
             </a:r>
-            <a:endParaRPr lang="en-US" sz="800" dirty="0"/>
+            <a:endParaRPr lang="en-US" sz="850" dirty="0"/>
           </a:p>
         </p:txBody>
       </p:sp>
@@ -4474,8 +4476,8 @@
         </p:nvSpPr>
         <p:spPr>
           <a:xfrm>
-            <a:off x="320040" y="4809744"/>
-            <a:ext cx="10259568" cy="347472"/>
+            <a:off x="320040" y="4528109"/>
+            <a:ext cx="10259568" cy="376733"/>
           </a:xfrm>
           <a:prstGeom prst="rect">
             <a:avLst/>
@@ -4499,7 +4501,7 @@
         </p:nvSpPr>
         <p:spPr>
           <a:xfrm>
-            <a:off x="10652760" y="5157216"/>
+            <a:off x="10652760" y="4904842"/>
             <a:ext cx="1216152" cy="0"/>
           </a:xfrm>
           <a:prstGeom prst="line">
@@ -4530,7 +4532,7 @@
         </p:blipFill>
         <p:spPr>
           <a:xfrm>
-            <a:off x="429768" y="4864608"/>
+            <a:off x="429768" y="4597603"/>
             <a:ext cx="237744" cy="237744"/>
           </a:xfrm>
           <a:prstGeom prst="rect">
@@ -4546,8 +4548,8 @@
         </p:nvSpPr>
         <p:spPr>
           <a:xfrm>
-            <a:off x="777240" y="4809744"/>
-            <a:ext cx="1307592" cy="347472"/>
+            <a:off x="777240" y="4528109"/>
+            <a:ext cx="1307592" cy="376733"/>
           </a:xfrm>
           <a:prstGeom prst="rect">
             <a:avLst/>
@@ -4585,12 +4587,12 @@
         </p:nvSpPr>
         <p:spPr>
           <a:xfrm>
-            <a:off x="3081528" y="4846320"/>
-            <a:ext cx="868680" cy="128016"/>
+            <a:off x="3081528" y="4569257"/>
+            <a:ext cx="868680" cy="137160"/>
           </a:xfrm>
           <a:prstGeom prst="roundRect">
             <a:avLst>
-              <a:gd name="adj" fmla="val 21429"/>
+              <a:gd name="adj" fmla="val 20000"/>
             </a:avLst>
           </a:prstGeom>
           <a:solidFill>
@@ -4610,7 +4612,7 @@
               <a:buNone/>
             </a:pPr>
             <a:r>
-              <a:rPr lang="en-US" sz="800" dirty="0">
+              <a:rPr lang="en-US" sz="850" dirty="0">
                 <a:solidFill>
                   <a:srgbClr val="14285A"/>
                 </a:solidFill>
@@ -4620,7 +4622,7 @@
               </a:rPr>
               <a:t>Cortex Archive</a:t>
             </a:r>
-            <a:endParaRPr lang="en-US" sz="800" dirty="0"/>
+            <a:endParaRPr lang="en-US" sz="850" dirty="0"/>
           </a:p>
         </p:txBody>
       </p:sp>
@@ -4632,12 +4634,12 @@
         </p:nvSpPr>
         <p:spPr>
           <a:xfrm>
-            <a:off x="3081528" y="4992624"/>
-            <a:ext cx="868680" cy="128016"/>
+            <a:off x="3081528" y="4726534"/>
+            <a:ext cx="868680" cy="137160"/>
           </a:xfrm>
           <a:prstGeom prst="roundRect">
             <a:avLst>
-              <a:gd name="adj" fmla="val 21429"/>
+              <a:gd name="adj" fmla="val 20000"/>
             </a:avLst>
           </a:prstGeom>
           <a:solidFill>
@@ -4657,7 +4659,7 @@
               <a:buNone/>
             </a:pPr>
             <a:r>
-              <a:rPr lang="en-US" sz="800" dirty="0">
+              <a:rPr lang="en-US" sz="850" dirty="0">
                 <a:solidFill>
                   <a:srgbClr val="14285A"/>
                 </a:solidFill>
@@ -4667,7 +4669,7 @@
               </a:rPr>
               <a:t>Cherwell</a:t>
             </a:r>
-            <a:endParaRPr lang="en-US" sz="800" dirty="0"/>
+            <a:endParaRPr lang="en-US" sz="850" dirty="0"/>
           </a:p>
         </p:txBody>
       </p:sp>
@@ -4679,8 +4681,8 @@
         </p:nvSpPr>
         <p:spPr>
           <a:xfrm>
-            <a:off x="320040" y="5157216"/>
-            <a:ext cx="10259568" cy="347472"/>
+            <a:off x="320040" y="4904842"/>
+            <a:ext cx="10259568" cy="365760"/>
           </a:xfrm>
           <a:prstGeom prst="rect">
             <a:avLst/>
@@ -4704,7 +4706,7 @@
         </p:nvSpPr>
         <p:spPr>
           <a:xfrm>
-            <a:off x="10652760" y="5504688"/>
+            <a:off x="10652760" y="5270602"/>
             <a:ext cx="1216152" cy="0"/>
           </a:xfrm>
           <a:prstGeom prst="line">
@@ -4735,7 +4737,7 @@
         </p:blipFill>
         <p:spPr>
           <a:xfrm>
-            <a:off x="429768" y="5212080"/>
+            <a:off x="429768" y="4968850"/>
             <a:ext cx="237744" cy="237744"/>
           </a:xfrm>
           <a:prstGeom prst="rect">
@@ -4751,8 +4753,8 @@
         </p:nvSpPr>
         <p:spPr>
           <a:xfrm>
-            <a:off x="777240" y="5157216"/>
-            <a:ext cx="1307592" cy="347472"/>
+            <a:off x="777240" y="4904842"/>
+            <a:ext cx="1307592" cy="365760"/>
           </a:xfrm>
           <a:prstGeom prst="rect">
             <a:avLst/>
@@ -4784,18 +4786,18 @@
       </p:sp>
       <p:sp>
         <p:nvSpPr>
-          <p:cNvPr id="103" name="Agent based Pilot (Release 1)"/>
-          <p:cNvSpPr/>
-          <p:nvPr/>
-        </p:nvSpPr>
-        <p:spPr>
-          <a:xfrm>
-            <a:off x="4023360" y="5193792"/>
-            <a:ext cx="868680" cy="128016"/>
+          <p:cNvPr id="103" name="Agent &amp;amp; Agentless Pilot (Release 1)"/>
+          <p:cNvSpPr/>
+          <p:nvPr/>
+        </p:nvSpPr>
+        <p:spPr>
+          <a:xfrm>
+            <a:off x="3081528" y="4959706"/>
+            <a:ext cx="868680" cy="256032"/>
           </a:xfrm>
           <a:prstGeom prst="roundRect">
             <a:avLst>
-              <a:gd name="adj" fmla="val 21429"/>
+              <a:gd name="adj" fmla="val 10714"/>
             </a:avLst>
           </a:prstGeom>
           <a:solidFill>
@@ -4815,7 +4817,7 @@
               <a:buNone/>
             </a:pPr>
             <a:r>
-              <a:rPr lang="en-US" sz="800" dirty="0">
+              <a:rPr lang="en-US" sz="850" dirty="0">
                 <a:solidFill>
                   <a:srgbClr val="14285A"/>
                 </a:solidFill>
@@ -4823,26 +4825,26 @@
                 <a:ea typeface="Calibri" pitchFamily="34" charset="-122"/>
                 <a:cs typeface="Calibri" pitchFamily="34" charset="-120"/>
               </a:rPr>
-              <a:t>Agent based Pilot</a:t>
-            </a:r>
-            <a:endParaRPr lang="en-US" sz="800" dirty="0"/>
-          </a:p>
-        </p:txBody>
-      </p:sp>
-      <p:sp>
-        <p:nvSpPr>
-          <p:cNvPr id="104" name="Agentless Pilot (Release 1)"/>
-          <p:cNvSpPr/>
-          <p:nvPr/>
-        </p:nvSpPr>
-        <p:spPr>
-          <a:xfrm>
-            <a:off x="4023360" y="5340096"/>
-            <a:ext cx="868680" cy="128016"/>
+              <a:t>Agent &amp; Agentless Pilot</a:t>
+            </a:r>
+            <a:endParaRPr lang="en-US" sz="850" dirty="0"/>
+          </a:p>
+        </p:txBody>
+      </p:sp>
+      <p:sp>
+        <p:nvSpPr>
+          <p:cNvPr id="104" name="Agent &amp;amp; Agentless Rollout (Release 1)"/>
+          <p:cNvSpPr/>
+          <p:nvPr/>
+        </p:nvSpPr>
+        <p:spPr>
+          <a:xfrm>
+            <a:off x="4023360" y="4959706"/>
+            <a:ext cx="868680" cy="256032"/>
           </a:xfrm>
           <a:prstGeom prst="roundRect">
             <a:avLst>
-              <a:gd name="adj" fmla="val 21429"/>
+              <a:gd name="adj" fmla="val 10714"/>
             </a:avLst>
           </a:prstGeom>
           <a:solidFill>
@@ -4862,7 +4864,7 @@
               <a:buNone/>
             </a:pPr>
             <a:r>
-              <a:rPr lang="en-US" sz="800" dirty="0">
+              <a:rPr lang="en-US" sz="850" dirty="0">
                 <a:solidFill>
                   <a:srgbClr val="14285A"/>
                 </a:solidFill>
@@ -4870,116 +4872,22 @@
                 <a:ea typeface="Calibri" pitchFamily="34" charset="-122"/>
                 <a:cs typeface="Calibri" pitchFamily="34" charset="-120"/>
               </a:rPr>
-              <a:t>Agentless Pilot</a:t>
-            </a:r>
-            <a:endParaRPr lang="en-US" sz="800" dirty="0"/>
-          </a:p>
-        </p:txBody>
-      </p:sp>
-      <p:sp>
-        <p:nvSpPr>
-          <p:cNvPr id="105" name="Agent based Rollout (Release 2)"/>
-          <p:cNvSpPr/>
-          <p:nvPr/>
-        </p:nvSpPr>
-        <p:spPr>
-          <a:xfrm>
-            <a:off x="5907024" y="5193792"/>
-            <a:ext cx="868680" cy="128016"/>
-          </a:xfrm>
-          <a:prstGeom prst="roundRect">
-            <a:avLst>
-              <a:gd name="adj" fmla="val 21429"/>
-            </a:avLst>
-          </a:prstGeom>
-          <a:solidFill>
-            <a:srgbClr val="A8DCD1"/>
-          </a:solidFill>
-          <a:ln w="6350">
-            <a:solidFill>
-              <a:srgbClr val="A8DCD1"/>
-            </a:solidFill>
-          </a:ln>
-        </p:spPr>
-        <p:txBody>
-          <a:bodyPr wrap="square" lIns="0" tIns="0" rIns="0" bIns="0" rtlCol="0" anchor="ctr"/>
-          <a:lstStyle/>
-          <a:p>
-            <a:pPr algn="ctr" indent="0" marL="0">
-              <a:buNone/>
-            </a:pPr>
-            <a:r>
-              <a:rPr lang="en-US" sz="700" dirty="0">
-                <a:solidFill>
-                  <a:srgbClr val="0F3F38"/>
-                </a:solidFill>
-                <a:latin typeface="Calibri" pitchFamily="34" charset="0"/>
-                <a:ea typeface="Calibri" pitchFamily="34" charset="-122"/>
-                <a:cs typeface="Calibri" pitchFamily="34" charset="-120"/>
-              </a:rPr>
-              <a:t>Agent based Rollout</a:t>
-            </a:r>
-            <a:endParaRPr lang="en-US" sz="700" dirty="0"/>
-          </a:p>
-        </p:txBody>
-      </p:sp>
-      <p:sp>
-        <p:nvSpPr>
-          <p:cNvPr id="106" name="Agentless rollout (Release 2)"/>
-          <p:cNvSpPr/>
-          <p:nvPr/>
-        </p:nvSpPr>
-        <p:spPr>
-          <a:xfrm>
-            <a:off x="5907024" y="5340096"/>
-            <a:ext cx="868680" cy="128016"/>
-          </a:xfrm>
-          <a:prstGeom prst="roundRect">
-            <a:avLst>
-              <a:gd name="adj" fmla="val 21429"/>
-            </a:avLst>
-          </a:prstGeom>
-          <a:solidFill>
-            <a:srgbClr val="A8DCD1"/>
-          </a:solidFill>
-          <a:ln w="6350">
-            <a:solidFill>
-              <a:srgbClr val="A8DCD1"/>
-            </a:solidFill>
-          </a:ln>
-        </p:spPr>
-        <p:txBody>
-          <a:bodyPr wrap="square" lIns="0" tIns="0" rIns="0" bIns="0" rtlCol="0" anchor="ctr"/>
-          <a:lstStyle/>
-          <a:p>
-            <a:pPr algn="ctr" indent="0" marL="0">
-              <a:buNone/>
-            </a:pPr>
-            <a:r>
-              <a:rPr lang="en-US" sz="800" dirty="0">
-                <a:solidFill>
-                  <a:srgbClr val="0F3F38"/>
-                </a:solidFill>
-                <a:latin typeface="Calibri" pitchFamily="34" charset="0"/>
-                <a:ea typeface="Calibri" pitchFamily="34" charset="-122"/>
-                <a:cs typeface="Calibri" pitchFamily="34" charset="-120"/>
-              </a:rPr>
-              <a:t>Agentless rollout</a:t>
-            </a:r>
-            <a:endParaRPr lang="en-US" sz="800" dirty="0"/>
-          </a:p>
-        </p:txBody>
-      </p:sp>
-      <p:sp>
-        <p:nvSpPr>
-          <p:cNvPr id="107" name="Row gridline 1"/>
-          <p:cNvSpPr/>
-          <p:nvPr/>
-        </p:nvSpPr>
-        <p:spPr>
-          <a:xfrm>
-            <a:off x="3044952" y="1463040"/>
-            <a:ext cx="0" cy="4041648"/>
+              <a:t>Agent &amp; Agentless Rollout</a:t>
+            </a:r>
+            <a:endParaRPr lang="en-US" sz="850" dirty="0"/>
+          </a:p>
+        </p:txBody>
+      </p:sp>
+      <p:sp>
+        <p:nvSpPr>
+          <p:cNvPr id="105" name="Row gridline 1"/>
+          <p:cNvSpPr/>
+          <p:nvPr/>
+        </p:nvSpPr>
+        <p:spPr>
+          <a:xfrm>
+            <a:off x="3044952" y="1243584"/>
+            <a:ext cx="0" cy="4027018"/>
           </a:xfrm>
           <a:prstGeom prst="line">
             <a:avLst/>
@@ -4995,14 +4903,14 @@
       </p:sp>
       <p:sp>
         <p:nvSpPr>
-          <p:cNvPr id="108" name="Row gridline 2"/>
-          <p:cNvSpPr/>
-          <p:nvPr/>
-        </p:nvSpPr>
-        <p:spPr>
-          <a:xfrm>
-            <a:off x="3986784" y="1463040"/>
-            <a:ext cx="0" cy="4041648"/>
+          <p:cNvPr id="106" name="Row gridline 2"/>
+          <p:cNvSpPr/>
+          <p:nvPr/>
+        </p:nvSpPr>
+        <p:spPr>
+          <a:xfrm>
+            <a:off x="3986784" y="1243584"/>
+            <a:ext cx="0" cy="4027018"/>
           </a:xfrm>
           <a:prstGeom prst="line">
             <a:avLst/>
@@ -5018,14 +4926,14 @@
       </p:sp>
       <p:sp>
         <p:nvSpPr>
-          <p:cNvPr id="109" name="Row gridline 3"/>
-          <p:cNvSpPr/>
-          <p:nvPr/>
-        </p:nvSpPr>
-        <p:spPr>
-          <a:xfrm>
-            <a:off x="4928616" y="1463040"/>
-            <a:ext cx="0" cy="4041648"/>
+          <p:cNvPr id="107" name="Row gridline 3"/>
+          <p:cNvSpPr/>
+          <p:nvPr/>
+        </p:nvSpPr>
+        <p:spPr>
+          <a:xfrm>
+            <a:off x="4928616" y="1243584"/>
+            <a:ext cx="0" cy="4027018"/>
           </a:xfrm>
           <a:prstGeom prst="line">
             <a:avLst/>
@@ -5041,14 +4949,14 @@
       </p:sp>
       <p:sp>
         <p:nvSpPr>
-          <p:cNvPr id="110" name="Row gridline 4"/>
-          <p:cNvSpPr/>
-          <p:nvPr/>
-        </p:nvSpPr>
-        <p:spPr>
-          <a:xfrm>
-            <a:off x="5870448" y="1463040"/>
-            <a:ext cx="0" cy="4041648"/>
+          <p:cNvPr id="108" name="Row gridline 4"/>
+          <p:cNvSpPr/>
+          <p:nvPr/>
+        </p:nvSpPr>
+        <p:spPr>
+          <a:xfrm>
+            <a:off x="5870448" y="1243584"/>
+            <a:ext cx="0" cy="4027018"/>
           </a:xfrm>
           <a:prstGeom prst="line">
             <a:avLst/>
@@ -5064,14 +4972,14 @@
       </p:sp>
       <p:sp>
         <p:nvSpPr>
-          <p:cNvPr id="111" name="Row gridline 5"/>
-          <p:cNvSpPr/>
-          <p:nvPr/>
-        </p:nvSpPr>
-        <p:spPr>
-          <a:xfrm>
-            <a:off x="6812280" y="1463040"/>
-            <a:ext cx="0" cy="4041648"/>
+          <p:cNvPr id="109" name="Row gridline 5"/>
+          <p:cNvSpPr/>
+          <p:nvPr/>
+        </p:nvSpPr>
+        <p:spPr>
+          <a:xfrm>
+            <a:off x="6812280" y="1243584"/>
+            <a:ext cx="0" cy="4027018"/>
           </a:xfrm>
           <a:prstGeom prst="line">
             <a:avLst/>
@@ -5087,14 +4995,14 @@
       </p:sp>
       <p:sp>
         <p:nvSpPr>
-          <p:cNvPr id="112" name="Row gridline 6"/>
-          <p:cNvSpPr/>
-          <p:nvPr/>
-        </p:nvSpPr>
-        <p:spPr>
-          <a:xfrm>
-            <a:off x="7754112" y="1463040"/>
-            <a:ext cx="0" cy="4041648"/>
+          <p:cNvPr id="110" name="Row gridline 6"/>
+          <p:cNvSpPr/>
+          <p:nvPr/>
+        </p:nvSpPr>
+        <p:spPr>
+          <a:xfrm>
+            <a:off x="7754112" y="1243584"/>
+            <a:ext cx="0" cy="4027018"/>
           </a:xfrm>
           <a:prstGeom prst="line">
             <a:avLst/>
@@ -5110,14 +5018,14 @@
       </p:sp>
       <p:sp>
         <p:nvSpPr>
-          <p:cNvPr id="113" name="Row gridline 7"/>
-          <p:cNvSpPr/>
-          <p:nvPr/>
-        </p:nvSpPr>
-        <p:spPr>
-          <a:xfrm>
-            <a:off x="8695944" y="1463040"/>
-            <a:ext cx="0" cy="4041648"/>
+          <p:cNvPr id="111" name="Row gridline 7"/>
+          <p:cNvSpPr/>
+          <p:nvPr/>
+        </p:nvSpPr>
+        <p:spPr>
+          <a:xfrm>
+            <a:off x="8695944" y="1243584"/>
+            <a:ext cx="0" cy="4027018"/>
           </a:xfrm>
           <a:prstGeom prst="line">
             <a:avLst/>
@@ -5133,14 +5041,14 @@
       </p:sp>
       <p:sp>
         <p:nvSpPr>
-          <p:cNvPr id="114" name="Row gridline 8"/>
-          <p:cNvSpPr/>
-          <p:nvPr/>
-        </p:nvSpPr>
-        <p:spPr>
-          <a:xfrm>
-            <a:off x="9637776" y="1463040"/>
-            <a:ext cx="0" cy="4041648"/>
+          <p:cNvPr id="112" name="Row gridline 8"/>
+          <p:cNvSpPr/>
+          <p:nvPr/>
+        </p:nvSpPr>
+        <p:spPr>
+          <a:xfrm>
+            <a:off x="9637776" y="1243584"/>
+            <a:ext cx="0" cy="4027018"/>
           </a:xfrm>
           <a:prstGeom prst="line">
             <a:avLst/>
@@ -5156,14 +5064,14 @@
       </p:sp>
       <p:sp>
         <p:nvSpPr>
-          <p:cNvPr id="115" name="Label divider"/>
-          <p:cNvSpPr/>
-          <p:nvPr/>
-        </p:nvSpPr>
-        <p:spPr>
-          <a:xfrm>
-            <a:off x="2103120" y="1463040"/>
-            <a:ext cx="0" cy="4041648"/>
+          <p:cNvPr id="113" name="Label divider"/>
+          <p:cNvSpPr/>
+          <p:nvPr/>
+        </p:nvSpPr>
+        <p:spPr>
+          <a:xfrm>
+            <a:off x="2103120" y="1243584"/>
+            <a:ext cx="0" cy="4027018"/>
           </a:xfrm>
           <a:prstGeom prst="line">
             <a:avLst/>
@@ -5179,14 +5087,14 @@
       </p:sp>
       <p:sp>
         <p:nvSpPr>
-          <p:cNvPr id="116" name="Milestone panel"/>
-          <p:cNvSpPr/>
-          <p:nvPr/>
-        </p:nvSpPr>
-        <p:spPr>
-          <a:xfrm>
-            <a:off x="320040" y="5568696"/>
-            <a:ext cx="11548872" cy="923544"/>
+          <p:cNvPr id="114" name="Milestone panel"/>
+          <p:cNvSpPr/>
+          <p:nvPr/>
+        </p:nvSpPr>
+        <p:spPr>
+          <a:xfrm>
+            <a:off x="320040" y="5334610"/>
+            <a:ext cx="11548872" cy="1157630"/>
           </a:xfrm>
           <a:prstGeom prst="rect">
             <a:avLst/>
@@ -5204,7 +5112,7 @@
       </p:sp>
       <p:pic>
         <p:nvPicPr>
-          <p:cNvPr id="117" name="Milestone icon" descr="preencoded.png">    </p:cNvPr>
+          <p:cNvPr id="115" name="Milestone icon" descr="preencoded.png">    </p:cNvPr>
           <p:cNvPicPr>
             <a:picLocks noChangeAspect="1"/>
           </p:cNvPicPr>
@@ -5218,7 +5126,7 @@
         </p:blipFill>
         <p:spPr>
           <a:xfrm>
-            <a:off x="429768" y="5751576"/>
+            <a:off x="429768" y="5517490"/>
             <a:ext cx="219456" cy="219456"/>
           </a:xfrm>
           <a:prstGeom prst="rect">
@@ -5228,13 +5136,13 @@
       </p:pic>
       <p:sp>
         <p:nvSpPr>
-          <p:cNvPr id="118" name="Milestone label"/>
+          <p:cNvPr id="116" name="Milestone label"/>
           <p:cNvSpPr txBox="1"/>
           <p:nvPr/>
         </p:nvSpPr>
         <p:spPr>
           <a:xfrm>
-            <a:off x="731520" y="5696712"/>
+            <a:off x="731520" y="5462626"/>
             <a:ext cx="1417320" cy="329184"/>
           </a:xfrm>
           <a:prstGeom prst="rect">
@@ -5267,13 +5175,13 @@
       </p:sp>
       <p:sp>
         <p:nvSpPr>
-          <p:cNvPr id="119" name="Milestone axis"/>
-          <p:cNvSpPr/>
-          <p:nvPr/>
-        </p:nvSpPr>
-        <p:spPr>
-          <a:xfrm>
-            <a:off x="2482596" y="5861304"/>
+          <p:cNvPr id="117" name="Milestone axis"/>
+          <p:cNvSpPr/>
+          <p:nvPr/>
+        </p:nvSpPr>
+        <p:spPr>
+          <a:xfrm>
+            <a:off x="2482596" y="5627218"/>
             <a:ext cx="9249156" cy="0"/>
           </a:xfrm>
           <a:prstGeom prst="line">
@@ -5291,13 +5199,13 @@
       </p:sp>
       <p:sp>
         <p:nvSpPr>
-          <p:cNvPr id="120" name="Milestone Oct-26 label"/>
+          <p:cNvPr id="118" name="Milestone Oct-26 label"/>
           <p:cNvSpPr txBox="1"/>
           <p:nvPr/>
         </p:nvSpPr>
         <p:spPr>
           <a:xfrm>
-            <a:off x="2208276" y="5614416"/>
+            <a:off x="2208276" y="5380330"/>
             <a:ext cx="731520" cy="164592"/>
           </a:xfrm>
           <a:prstGeom prst="rect">
@@ -5330,13 +5238,13 @@
       </p:sp>
       <p:sp>
         <p:nvSpPr>
-          <p:cNvPr id="121" name="Milestone Oct-26 marker"/>
-          <p:cNvSpPr/>
-          <p:nvPr/>
-        </p:nvSpPr>
-        <p:spPr>
-          <a:xfrm>
-            <a:off x="2528316" y="5815584"/>
+          <p:cNvPr id="119" name="Milestone Oct-26 marker"/>
+          <p:cNvSpPr/>
+          <p:nvPr/>
+        </p:nvSpPr>
+        <p:spPr>
+          <a:xfrm>
+            <a:off x="2528316" y="5581498"/>
             <a:ext cx="91440" cy="91440"/>
           </a:xfrm>
           <a:prstGeom prst="ellipse">
@@ -5355,13 +5263,13 @@
       </p:sp>
       <p:sp>
         <p:nvSpPr>
-          <p:cNvPr id="122" name="Milestone Nov-26 label"/>
+          <p:cNvPr id="120" name="Milestone Nov-26 label"/>
           <p:cNvSpPr txBox="1"/>
           <p:nvPr/>
         </p:nvSpPr>
         <p:spPr>
           <a:xfrm>
-            <a:off x="3150108" y="5614416"/>
+            <a:off x="3150108" y="5380330"/>
             <a:ext cx="731520" cy="164592"/>
           </a:xfrm>
           <a:prstGeom prst="rect">
@@ -5394,13 +5302,13 @@
       </p:sp>
       <p:sp>
         <p:nvSpPr>
-          <p:cNvPr id="123" name="Milestone Nov-26 marker"/>
-          <p:cNvSpPr/>
-          <p:nvPr/>
-        </p:nvSpPr>
-        <p:spPr>
-          <a:xfrm>
-            <a:off x="3456432" y="5801868"/>
+          <p:cNvPr id="121" name="Milestone Nov-26 marker"/>
+          <p:cNvSpPr/>
+          <p:nvPr/>
+        </p:nvSpPr>
+        <p:spPr>
+          <a:xfrm>
+            <a:off x="3456432" y="5567782"/>
             <a:ext cx="118872" cy="118872"/>
           </a:xfrm>
           <a:prstGeom prst="ellipse">
@@ -5419,14 +5327,14 @@
       </p:sp>
       <p:sp>
         <p:nvSpPr>
-          <p:cNvPr id="124" name="Milestones Nov-26"/>
+          <p:cNvPr id="122" name="Milestones Nov-26"/>
           <p:cNvSpPr txBox="1"/>
           <p:nvPr/>
         </p:nvSpPr>
         <p:spPr>
           <a:xfrm>
-            <a:off x="3470148" y="5952744"/>
-            <a:ext cx="987552" cy="502920"/>
+            <a:off x="3451860" y="5718658"/>
+            <a:ext cx="914400" cy="737006"/>
           </a:xfrm>
           <a:prstGeom prst="rect">
             <a:avLst/>
@@ -5443,7 +5351,7 @@
               <a:buChar char="●"/>
             </a:pPr>
             <a:r>
-              <a:rPr lang="en-US" sz="800" dirty="0">
+              <a:rPr lang="en-US" sz="800" b="1" dirty="0">
                 <a:solidFill>
                   <a:srgbClr val="1F2937"/>
                 </a:solidFill>
@@ -5455,92 +5363,6 @@
             </a:r>
             <a:endParaRPr lang="en-US" sz="800" dirty="0"/>
           </a:p>
-        </p:txBody>
-      </p:sp>
-      <p:sp>
-        <p:nvSpPr>
-          <p:cNvPr id="125" name="Milestone Dec-26 label"/>
-          <p:cNvSpPr txBox="1"/>
-          <p:nvPr/>
-        </p:nvSpPr>
-        <p:spPr>
-          <a:xfrm>
-            <a:off x="4091940" y="5614416"/>
-            <a:ext cx="731520" cy="164592"/>
-          </a:xfrm>
-          <a:prstGeom prst="rect">
-            <a:avLst/>
-          </a:prstGeom>
-          <a:noFill/>
-          <a:ln/>
-        </p:spPr>
-        <p:txBody>
-          <a:bodyPr wrap="square" lIns="0" tIns="0" rIns="0" bIns="0" rtlCol="0" anchor="ctr"/>
-          <a:lstStyle/>
-          <a:p>
-            <a:pPr algn="ctr" indent="0" marL="0">
-              <a:buNone/>
-            </a:pPr>
-            <a:r>
-              <a:rPr lang="en-US" sz="900" dirty="0">
-                <a:solidFill>
-                  <a:srgbClr val="374151"/>
-                </a:solidFill>
-                <a:latin typeface="Calibri" pitchFamily="34" charset="0"/>
-                <a:ea typeface="Calibri" pitchFamily="34" charset="-122"/>
-                <a:cs typeface="Calibri" pitchFamily="34" charset="-120"/>
-              </a:rPr>
-              <a:t>Dec-26</a:t>
-            </a:r>
-            <a:endParaRPr lang="en-US" sz="900" dirty="0"/>
-          </a:p>
-        </p:txBody>
-      </p:sp>
-      <p:sp>
-        <p:nvSpPr>
-          <p:cNvPr id="126" name="Milestone Dec-26 marker"/>
-          <p:cNvSpPr/>
-          <p:nvPr/>
-        </p:nvSpPr>
-        <p:spPr>
-          <a:xfrm>
-            <a:off x="4398264" y="5801868"/>
-            <a:ext cx="118872" cy="118872"/>
-          </a:xfrm>
-          <a:prstGeom prst="ellipse">
-            <a:avLst/>
-          </a:prstGeom>
-          <a:solidFill>
-            <a:srgbClr val="14285A"/>
-          </a:solidFill>
-          <a:ln w="12700">
-            <a:solidFill>
-              <a:srgbClr val="FFFFFF"/>
-            </a:solidFill>
-            <a:prstDash val="solid"/>
-          </a:ln>
-        </p:spPr>
-      </p:sp>
-      <p:sp>
-        <p:nvSpPr>
-          <p:cNvPr id="127" name="Milestones Dec-26"/>
-          <p:cNvSpPr txBox="1"/>
-          <p:nvPr/>
-        </p:nvSpPr>
-        <p:spPr>
-          <a:xfrm>
-            <a:off x="4411980" y="5952744"/>
-            <a:ext cx="1737360" cy="502920"/>
-          </a:xfrm>
-          <a:prstGeom prst="rect">
-            <a:avLst/>
-          </a:prstGeom>
-          <a:noFill/>
-          <a:ln/>
-        </p:spPr>
-        <p:txBody>
-          <a:bodyPr wrap="square" lIns="0" tIns="0" rIns="0" bIns="0" rtlCol="0" anchor="t"/>
-          <a:lstStyle/>
           <a:p>
             <a:pPr marL="114300" indent="-114300">
               <a:buSzPct val="100000"/>
@@ -5555,10 +5377,96 @@
                 <a:ea typeface="Calibri" pitchFamily="34" charset="-122"/>
                 <a:cs typeface="Calibri" pitchFamily="34" charset="-120"/>
               </a:rPr>
-              <a:t>Agent based Pilot</a:t>
+              <a:t>Agent &amp; Agentless Pilot</a:t>
             </a:r>
             <a:endParaRPr lang="en-US" sz="800" dirty="0"/>
           </a:p>
+        </p:txBody>
+      </p:sp>
+      <p:sp>
+        <p:nvSpPr>
+          <p:cNvPr id="123" name="Milestone Dec-26 label"/>
+          <p:cNvSpPr txBox="1"/>
+          <p:nvPr/>
+        </p:nvSpPr>
+        <p:spPr>
+          <a:xfrm>
+            <a:off x="4091940" y="5380330"/>
+            <a:ext cx="731520" cy="164592"/>
+          </a:xfrm>
+          <a:prstGeom prst="rect">
+            <a:avLst/>
+          </a:prstGeom>
+          <a:noFill/>
+          <a:ln/>
+        </p:spPr>
+        <p:txBody>
+          <a:bodyPr wrap="square" lIns="0" tIns="0" rIns="0" bIns="0" rtlCol="0" anchor="ctr"/>
+          <a:lstStyle/>
+          <a:p>
+            <a:pPr algn="ctr" indent="0" marL="0">
+              <a:buNone/>
+            </a:pPr>
+            <a:r>
+              <a:rPr lang="en-US" sz="900" dirty="0">
+                <a:solidFill>
+                  <a:srgbClr val="374151"/>
+                </a:solidFill>
+                <a:latin typeface="Calibri" pitchFamily="34" charset="0"/>
+                <a:ea typeface="Calibri" pitchFamily="34" charset="-122"/>
+                <a:cs typeface="Calibri" pitchFamily="34" charset="-120"/>
+              </a:rPr>
+              <a:t>Dec-26</a:t>
+            </a:r>
+            <a:endParaRPr lang="en-US" sz="900" dirty="0"/>
+          </a:p>
+        </p:txBody>
+      </p:sp>
+      <p:sp>
+        <p:nvSpPr>
+          <p:cNvPr id="124" name="Milestone Dec-26 marker"/>
+          <p:cNvSpPr/>
+          <p:nvPr/>
+        </p:nvSpPr>
+        <p:spPr>
+          <a:xfrm>
+            <a:off x="4398264" y="5567782"/>
+            <a:ext cx="118872" cy="118872"/>
+          </a:xfrm>
+          <a:prstGeom prst="ellipse">
+            <a:avLst/>
+          </a:prstGeom>
+          <a:solidFill>
+            <a:srgbClr val="14285A"/>
+          </a:solidFill>
+          <a:ln w="12700">
+            <a:solidFill>
+              <a:srgbClr val="FFFFFF"/>
+            </a:solidFill>
+            <a:prstDash val="solid"/>
+          </a:ln>
+        </p:spPr>
+      </p:sp>
+      <p:sp>
+        <p:nvSpPr>
+          <p:cNvPr id="125" name="Milestones Dec-26"/>
+          <p:cNvSpPr txBox="1"/>
+          <p:nvPr/>
+        </p:nvSpPr>
+        <p:spPr>
+          <a:xfrm>
+            <a:off x="4393692" y="5718658"/>
+            <a:ext cx="914400" cy="737006"/>
+          </a:xfrm>
+          <a:prstGeom prst="rect">
+            <a:avLst/>
+          </a:prstGeom>
+          <a:noFill/>
+          <a:ln/>
+        </p:spPr>
+        <p:txBody>
+          <a:bodyPr wrap="square" lIns="0" tIns="0" rIns="0" bIns="0" rtlCol="0" anchor="t"/>
+          <a:lstStyle/>
           <a:p>
             <a:pPr marL="114300" indent="-114300">
               <a:buSzPct val="100000"/>
@@ -5573,7 +5481,7 @@
                 <a:ea typeface="Calibri" pitchFamily="34" charset="-122"/>
                 <a:cs typeface="Calibri" pitchFamily="34" charset="-120"/>
               </a:rPr>
-              <a:t>Agentless Pilot</a:t>
+              <a:t>Cherwell Shutdown</a:t>
             </a:r>
             <a:endParaRPr lang="en-US" sz="800" dirty="0"/>
           </a:p>
@@ -5591,7 +5499,7 @@
                 <a:ea typeface="Calibri" pitchFamily="34" charset="-122"/>
                 <a:cs typeface="Calibri" pitchFamily="34" charset="-120"/>
               </a:rPr>
-              <a:t>Cherwell Shutdown</a:t>
+              <a:t>Agent &amp; Agentless Rollout (may slip to Jan)</a:t>
             </a:r>
             <a:endParaRPr lang="en-US" sz="800" dirty="0"/>
           </a:p>
@@ -5599,13 +5507,13 @@
       </p:sp>
       <p:sp>
         <p:nvSpPr>
-          <p:cNvPr id="128" name="Milestone Jan-27 label"/>
+          <p:cNvPr id="126" name="Milestone Jan-27 label"/>
           <p:cNvSpPr txBox="1"/>
           <p:nvPr/>
         </p:nvSpPr>
         <p:spPr>
           <a:xfrm>
-            <a:off x="5033772" y="5614416"/>
+            <a:off x="5033772" y="5380330"/>
             <a:ext cx="731520" cy="164592"/>
           </a:xfrm>
           <a:prstGeom prst="rect">
@@ -5638,20 +5546,20 @@
       </p:sp>
       <p:sp>
         <p:nvSpPr>
-          <p:cNvPr id="129" name="Milestone Jan-27 marker"/>
-          <p:cNvSpPr/>
-          <p:nvPr/>
-        </p:nvSpPr>
-        <p:spPr>
-          <a:xfrm>
-            <a:off x="5353812" y="5815584"/>
-            <a:ext cx="91440" cy="91440"/>
+          <p:cNvPr id="127" name="Milestone Jan-27 marker"/>
+          <p:cNvSpPr/>
+          <p:nvPr/>
+        </p:nvSpPr>
+        <p:spPr>
+          <a:xfrm>
+            <a:off x="5340096" y="5567782"/>
+            <a:ext cx="118872" cy="118872"/>
           </a:xfrm>
           <a:prstGeom prst="ellipse">
             <a:avLst/>
           </a:prstGeom>
           <a:solidFill>
-            <a:srgbClr val="A3B1C6"/>
+            <a:srgbClr val="14285A"/>
           </a:solidFill>
           <a:ln w="12700">
             <a:solidFill>
@@ -5663,78 +5571,14 @@
       </p:sp>
       <p:sp>
         <p:nvSpPr>
-          <p:cNvPr id="130" name="Milestone Feb-27 label"/>
+          <p:cNvPr id="128" name="Milestones Jan-27"/>
           <p:cNvSpPr txBox="1"/>
           <p:nvPr/>
         </p:nvSpPr>
         <p:spPr>
           <a:xfrm>
-            <a:off x="5975604" y="5614416"/>
-            <a:ext cx="731520" cy="164592"/>
-          </a:xfrm>
-          <a:prstGeom prst="rect">
-            <a:avLst/>
-          </a:prstGeom>
-          <a:noFill/>
-          <a:ln/>
-        </p:spPr>
-        <p:txBody>
-          <a:bodyPr wrap="square" lIns="0" tIns="0" rIns="0" bIns="0" rtlCol="0" anchor="ctr"/>
-          <a:lstStyle/>
-          <a:p>
-            <a:pPr algn="ctr" indent="0" marL="0">
-              <a:buNone/>
-            </a:pPr>
-            <a:r>
-              <a:rPr lang="en-US" sz="900" dirty="0">
-                <a:solidFill>
-                  <a:srgbClr val="374151"/>
-                </a:solidFill>
-                <a:latin typeface="Calibri" pitchFamily="34" charset="0"/>
-                <a:ea typeface="Calibri" pitchFamily="34" charset="-122"/>
-                <a:cs typeface="Calibri" pitchFamily="34" charset="-120"/>
-              </a:rPr>
-              <a:t>Feb-27</a:t>
-            </a:r>
-            <a:endParaRPr lang="en-US" sz="900" dirty="0"/>
-          </a:p>
-        </p:txBody>
-      </p:sp>
-      <p:sp>
-        <p:nvSpPr>
-          <p:cNvPr id="131" name="Milestone Feb-27 marker"/>
-          <p:cNvSpPr/>
-          <p:nvPr/>
-        </p:nvSpPr>
-        <p:spPr>
-          <a:xfrm>
-            <a:off x="6281928" y="5801868"/>
-            <a:ext cx="118872" cy="118872"/>
-          </a:xfrm>
-          <a:prstGeom prst="ellipse">
-            <a:avLst/>
-          </a:prstGeom>
-          <a:solidFill>
-            <a:srgbClr val="14285A"/>
-          </a:solidFill>
-          <a:ln w="12700">
-            <a:solidFill>
-              <a:srgbClr val="FFFFFF"/>
-            </a:solidFill>
-            <a:prstDash val="solid"/>
-          </a:ln>
-        </p:spPr>
-      </p:sp>
-      <p:sp>
-        <p:nvSpPr>
-          <p:cNvPr id="132" name="Milestones Feb-27"/>
-          <p:cNvSpPr txBox="1"/>
-          <p:nvPr/>
-        </p:nvSpPr>
-        <p:spPr>
-          <a:xfrm>
-            <a:off x="6295644" y="5952744"/>
-            <a:ext cx="1737360" cy="502920"/>
+            <a:off x="5335524" y="5718658"/>
+            <a:ext cx="914400" cy="737006"/>
           </a:xfrm>
           <a:prstGeom prst="rect">
             <a:avLst/>
@@ -5751,7 +5595,7 @@
               <a:buChar char="●"/>
             </a:pPr>
             <a:r>
-              <a:rPr lang="en-US" sz="800" dirty="0">
+              <a:rPr lang="en-US" sz="800" b="1" dirty="0">
                 <a:solidFill>
                   <a:srgbClr val="1F2937"/>
                 </a:solidFill>
@@ -5759,17 +5603,103 @@
                 <a:ea typeface="Calibri" pitchFamily="34" charset="-122"/>
                 <a:cs typeface="Calibri" pitchFamily="34" charset="-120"/>
               </a:rPr>
-              <a:t>Agent based Rollout</a:t>
+              <a:t>Golden Asset Record configured (may slip to Feb)</a:t>
             </a:r>
             <a:endParaRPr lang="en-US" sz="800" dirty="0"/>
           </a:p>
+        </p:txBody>
+      </p:sp>
+      <p:sp>
+        <p:nvSpPr>
+          <p:cNvPr id="129" name="Milestone Feb-27 label"/>
+          <p:cNvSpPr txBox="1"/>
+          <p:nvPr/>
+        </p:nvSpPr>
+        <p:spPr>
+          <a:xfrm>
+            <a:off x="5975604" y="5380330"/>
+            <a:ext cx="731520" cy="164592"/>
+          </a:xfrm>
+          <a:prstGeom prst="rect">
+            <a:avLst/>
+          </a:prstGeom>
+          <a:noFill/>
+          <a:ln/>
+        </p:spPr>
+        <p:txBody>
+          <a:bodyPr wrap="square" lIns="0" tIns="0" rIns="0" bIns="0" rtlCol="0" anchor="ctr"/>
+          <a:lstStyle/>
+          <a:p>
+            <a:pPr algn="ctr" indent="0" marL="0">
+              <a:buNone/>
+            </a:pPr>
+            <a:r>
+              <a:rPr lang="en-US" sz="900" dirty="0">
+                <a:solidFill>
+                  <a:srgbClr val="374151"/>
+                </a:solidFill>
+                <a:latin typeface="Calibri" pitchFamily="34" charset="0"/>
+                <a:ea typeface="Calibri" pitchFamily="34" charset="-122"/>
+                <a:cs typeface="Calibri" pitchFamily="34" charset="-120"/>
+              </a:rPr>
+              <a:t>Feb-27</a:t>
+            </a:r>
+            <a:endParaRPr lang="en-US" sz="900" dirty="0"/>
+          </a:p>
+        </p:txBody>
+      </p:sp>
+      <p:sp>
+        <p:nvSpPr>
+          <p:cNvPr id="130" name="Milestone Feb-27 marker"/>
+          <p:cNvSpPr/>
+          <p:nvPr/>
+        </p:nvSpPr>
+        <p:spPr>
+          <a:xfrm>
+            <a:off x="6281928" y="5567782"/>
+            <a:ext cx="118872" cy="118872"/>
+          </a:xfrm>
+          <a:prstGeom prst="ellipse">
+            <a:avLst/>
+          </a:prstGeom>
+          <a:solidFill>
+            <a:srgbClr val="14285A"/>
+          </a:solidFill>
+          <a:ln w="12700">
+            <a:solidFill>
+              <a:srgbClr val="FFFFFF"/>
+            </a:solidFill>
+            <a:prstDash val="solid"/>
+          </a:ln>
+        </p:spPr>
+      </p:sp>
+      <p:sp>
+        <p:nvSpPr>
+          <p:cNvPr id="131" name="Milestones Feb-27"/>
+          <p:cNvSpPr txBox="1"/>
+          <p:nvPr/>
+        </p:nvSpPr>
+        <p:spPr>
+          <a:xfrm>
+            <a:off x="6277356" y="5718658"/>
+            <a:ext cx="1737360" cy="737006"/>
+          </a:xfrm>
+          <a:prstGeom prst="rect">
+            <a:avLst/>
+          </a:prstGeom>
+          <a:noFill/>
+          <a:ln/>
+        </p:spPr>
+        <p:txBody>
+          <a:bodyPr wrap="square" lIns="0" tIns="0" rIns="0" bIns="0" rtlCol="0" anchor="t"/>
+          <a:lstStyle/>
           <a:p>
             <a:pPr marL="114300" indent="-114300">
               <a:buSzPct val="100000"/>
               <a:buChar char="●"/>
             </a:pPr>
             <a:r>
-              <a:rPr lang="en-US" sz="800" dirty="0">
+              <a:rPr lang="en-US" sz="800" b="1" dirty="0">
                 <a:solidFill>
                   <a:srgbClr val="1F2937"/>
                 </a:solidFill>
@@ -5777,7 +5707,7 @@
                 <a:ea typeface="Calibri" pitchFamily="34" charset="-122"/>
                 <a:cs typeface="Calibri" pitchFamily="34" charset="-120"/>
               </a:rPr>
-              <a:t>Agentless Rollout</a:t>
+              <a:t>ME SDP Release 2 Go Live</a:t>
             </a:r>
             <a:endParaRPr lang="en-US" sz="800" dirty="0"/>
           </a:p>
@@ -5799,6 +5729,220 @@
             </a:r>
             <a:endParaRPr lang="en-US" sz="800" dirty="0"/>
           </a:p>
+        </p:txBody>
+      </p:sp>
+      <p:sp>
+        <p:nvSpPr>
+          <p:cNvPr id="132" name="Milestone Mar-27 label"/>
+          <p:cNvSpPr txBox="1"/>
+          <p:nvPr/>
+        </p:nvSpPr>
+        <p:spPr>
+          <a:xfrm>
+            <a:off x="6917436" y="5380330"/>
+            <a:ext cx="731520" cy="164592"/>
+          </a:xfrm>
+          <a:prstGeom prst="rect">
+            <a:avLst/>
+          </a:prstGeom>
+          <a:noFill/>
+          <a:ln/>
+        </p:spPr>
+        <p:txBody>
+          <a:bodyPr wrap="square" lIns="0" tIns="0" rIns="0" bIns="0" rtlCol="0" anchor="ctr"/>
+          <a:lstStyle/>
+          <a:p>
+            <a:pPr algn="ctr" indent="0" marL="0">
+              <a:buNone/>
+            </a:pPr>
+            <a:r>
+              <a:rPr lang="en-US" sz="900" dirty="0">
+                <a:solidFill>
+                  <a:srgbClr val="374151"/>
+                </a:solidFill>
+                <a:latin typeface="Calibri" pitchFamily="34" charset="0"/>
+                <a:ea typeface="Calibri" pitchFamily="34" charset="-122"/>
+                <a:cs typeface="Calibri" pitchFamily="34" charset="-120"/>
+              </a:rPr>
+              <a:t>Mar-27</a:t>
+            </a:r>
+            <a:endParaRPr lang="en-US" sz="900" dirty="0"/>
+          </a:p>
+        </p:txBody>
+      </p:sp>
+      <p:sp>
+        <p:nvSpPr>
+          <p:cNvPr id="133" name="Milestone Mar-27 marker"/>
+          <p:cNvSpPr/>
+          <p:nvPr/>
+        </p:nvSpPr>
+        <p:spPr>
+          <a:xfrm>
+            <a:off x="7237476" y="5581498"/>
+            <a:ext cx="91440" cy="91440"/>
+          </a:xfrm>
+          <a:prstGeom prst="ellipse">
+            <a:avLst/>
+          </a:prstGeom>
+          <a:solidFill>
+            <a:srgbClr val="A3B1C6"/>
+          </a:solidFill>
+          <a:ln w="12700">
+            <a:solidFill>
+              <a:srgbClr val="FFFFFF"/>
+            </a:solidFill>
+            <a:prstDash val="solid"/>
+          </a:ln>
+        </p:spPr>
+      </p:sp>
+      <p:sp>
+        <p:nvSpPr>
+          <p:cNvPr id="134" name="Milestone Apr-27 label"/>
+          <p:cNvSpPr txBox="1"/>
+          <p:nvPr/>
+        </p:nvSpPr>
+        <p:spPr>
+          <a:xfrm>
+            <a:off x="7859268" y="5380330"/>
+            <a:ext cx="731520" cy="164592"/>
+          </a:xfrm>
+          <a:prstGeom prst="rect">
+            <a:avLst/>
+          </a:prstGeom>
+          <a:noFill/>
+          <a:ln/>
+        </p:spPr>
+        <p:txBody>
+          <a:bodyPr wrap="square" lIns="0" tIns="0" rIns="0" bIns="0" rtlCol="0" anchor="ctr"/>
+          <a:lstStyle/>
+          <a:p>
+            <a:pPr algn="ctr" indent="0" marL="0">
+              <a:buNone/>
+            </a:pPr>
+            <a:r>
+              <a:rPr lang="en-US" sz="900" dirty="0">
+                <a:solidFill>
+                  <a:srgbClr val="374151"/>
+                </a:solidFill>
+                <a:latin typeface="Calibri" pitchFamily="34" charset="0"/>
+                <a:ea typeface="Calibri" pitchFamily="34" charset="-122"/>
+                <a:cs typeface="Calibri" pitchFamily="34" charset="-120"/>
+              </a:rPr>
+              <a:t>Apr-27</a:t>
+            </a:r>
+            <a:endParaRPr lang="en-US" sz="900" dirty="0"/>
+          </a:p>
+        </p:txBody>
+      </p:sp>
+      <p:sp>
+        <p:nvSpPr>
+          <p:cNvPr id="135" name="Milestone Apr-27 marker"/>
+          <p:cNvSpPr/>
+          <p:nvPr/>
+        </p:nvSpPr>
+        <p:spPr>
+          <a:xfrm>
+            <a:off x="8179308" y="5581498"/>
+            <a:ext cx="91440" cy="91440"/>
+          </a:xfrm>
+          <a:prstGeom prst="ellipse">
+            <a:avLst/>
+          </a:prstGeom>
+          <a:solidFill>
+            <a:srgbClr val="A3B1C6"/>
+          </a:solidFill>
+          <a:ln w="12700">
+            <a:solidFill>
+              <a:srgbClr val="FFFFFF"/>
+            </a:solidFill>
+            <a:prstDash val="solid"/>
+          </a:ln>
+        </p:spPr>
+      </p:sp>
+      <p:sp>
+        <p:nvSpPr>
+          <p:cNvPr id="136" name="Milestone May-27 label"/>
+          <p:cNvSpPr txBox="1"/>
+          <p:nvPr/>
+        </p:nvSpPr>
+        <p:spPr>
+          <a:xfrm>
+            <a:off x="8801100" y="5380330"/>
+            <a:ext cx="731520" cy="164592"/>
+          </a:xfrm>
+          <a:prstGeom prst="rect">
+            <a:avLst/>
+          </a:prstGeom>
+          <a:noFill/>
+          <a:ln/>
+        </p:spPr>
+        <p:txBody>
+          <a:bodyPr wrap="square" lIns="0" tIns="0" rIns="0" bIns="0" rtlCol="0" anchor="ctr"/>
+          <a:lstStyle/>
+          <a:p>
+            <a:pPr algn="ctr" indent="0" marL="0">
+              <a:buNone/>
+            </a:pPr>
+            <a:r>
+              <a:rPr lang="en-US" sz="900" dirty="0">
+                <a:solidFill>
+                  <a:srgbClr val="374151"/>
+                </a:solidFill>
+                <a:latin typeface="Calibri" pitchFamily="34" charset="0"/>
+                <a:ea typeface="Calibri" pitchFamily="34" charset="-122"/>
+                <a:cs typeface="Calibri" pitchFamily="34" charset="-120"/>
+              </a:rPr>
+              <a:t>May-27</a:t>
+            </a:r>
+            <a:endParaRPr lang="en-US" sz="900" dirty="0"/>
+          </a:p>
+        </p:txBody>
+      </p:sp>
+      <p:sp>
+        <p:nvSpPr>
+          <p:cNvPr id="137" name="Milestone May-27 marker"/>
+          <p:cNvSpPr/>
+          <p:nvPr/>
+        </p:nvSpPr>
+        <p:spPr>
+          <a:xfrm>
+            <a:off x="9107424" y="5567782"/>
+            <a:ext cx="118872" cy="118872"/>
+          </a:xfrm>
+          <a:prstGeom prst="ellipse">
+            <a:avLst/>
+          </a:prstGeom>
+          <a:solidFill>
+            <a:srgbClr val="14285A"/>
+          </a:solidFill>
+          <a:ln w="12700">
+            <a:solidFill>
+              <a:srgbClr val="FFFFFF"/>
+            </a:solidFill>
+            <a:prstDash val="solid"/>
+          </a:ln>
+        </p:spPr>
+      </p:sp>
+      <p:sp>
+        <p:nvSpPr>
+          <p:cNvPr id="138" name="Milestones May-27"/>
+          <p:cNvSpPr txBox="1"/>
+          <p:nvPr/>
+        </p:nvSpPr>
+        <p:spPr>
+          <a:xfrm>
+            <a:off x="9102852" y="5718658"/>
+            <a:ext cx="1737360" cy="737006"/>
+          </a:xfrm>
+          <a:prstGeom prst="rect">
+            <a:avLst/>
+          </a:prstGeom>
+          <a:noFill/>
+          <a:ln/>
+        </p:spPr>
+        <p:txBody>
+          <a:bodyPr wrap="square" lIns="0" tIns="0" rIns="0" bIns="0" rtlCol="0" anchor="t"/>
+          <a:lstStyle/>
           <a:p>
             <a:pPr marL="114300" indent="-114300">
               <a:buSzPct val="100000"/>
@@ -5813,7 +5957,7 @@
                 <a:ea typeface="Calibri" pitchFamily="34" charset="-122"/>
                 <a:cs typeface="Calibri" pitchFamily="34" charset="-120"/>
               </a:rPr>
-              <a:t>ME SDP Release 2 Go Live</a:t>
+              <a:t>ME SDP Release 3 Go Live</a:t>
             </a:r>
             <a:endParaRPr lang="en-US" sz="800" dirty="0"/>
           </a:p>
@@ -5821,13 +5965,13 @@
       </p:sp>
       <p:sp>
         <p:nvSpPr>
-          <p:cNvPr id="133" name="Milestone Mar-27 label"/>
+          <p:cNvPr id="139" name="Milestone Jun-27 label"/>
           <p:cNvSpPr txBox="1"/>
           <p:nvPr/>
         </p:nvSpPr>
         <p:spPr>
           <a:xfrm>
-            <a:off x="6917436" y="5614416"/>
+            <a:off x="9742932" y="5380330"/>
             <a:ext cx="731520" cy="164592"/>
           </a:xfrm>
           <a:prstGeom prst="rect">
@@ -5852,7 +5996,7 @@
                 <a:ea typeface="Calibri" pitchFamily="34" charset="-122"/>
                 <a:cs typeface="Calibri" pitchFamily="34" charset="-120"/>
               </a:rPr>
-              <a:t>Mar-27</a:t>
+              <a:t>Jun-27</a:t>
             </a:r>
             <a:endParaRPr lang="en-US" sz="900" dirty="0"/>
           </a:p>
@@ -5860,13 +6004,13 @@
       </p:sp>
       <p:sp>
         <p:nvSpPr>
-          <p:cNvPr id="134" name="Milestone Mar-27 marker"/>
-          <p:cNvSpPr/>
-          <p:nvPr/>
-        </p:nvSpPr>
-        <p:spPr>
-          <a:xfrm>
-            <a:off x="7237476" y="5815584"/>
+          <p:cNvPr id="140" name="Milestone Jun-27 marker"/>
+          <p:cNvSpPr/>
+          <p:nvPr/>
+        </p:nvSpPr>
+        <p:spPr>
+          <a:xfrm>
+            <a:off x="10062972" y="5581498"/>
             <a:ext cx="91440" cy="91440"/>
           </a:xfrm>
           <a:prstGeom prst="ellipse">
@@ -5885,239 +6029,7 @@
       </p:sp>
       <p:sp>
         <p:nvSpPr>
-          <p:cNvPr id="135" name="Milestone Apr-27 label"/>
-          <p:cNvSpPr txBox="1"/>
-          <p:nvPr/>
-        </p:nvSpPr>
-        <p:spPr>
-          <a:xfrm>
-            <a:off x="7859268" y="5614416"/>
-            <a:ext cx="731520" cy="164592"/>
-          </a:xfrm>
-          <a:prstGeom prst="rect">
-            <a:avLst/>
-          </a:prstGeom>
-          <a:noFill/>
-          <a:ln/>
-        </p:spPr>
-        <p:txBody>
-          <a:bodyPr wrap="square" lIns="0" tIns="0" rIns="0" bIns="0" rtlCol="0" anchor="ctr"/>
-          <a:lstStyle/>
-          <a:p>
-            <a:pPr algn="ctr" indent="0" marL="0">
-              <a:buNone/>
-            </a:pPr>
-            <a:r>
-              <a:rPr lang="en-US" sz="900" dirty="0">
-                <a:solidFill>
-                  <a:srgbClr val="374151"/>
-                </a:solidFill>
-                <a:latin typeface="Calibri" pitchFamily="34" charset="0"/>
-                <a:ea typeface="Calibri" pitchFamily="34" charset="-122"/>
-                <a:cs typeface="Calibri" pitchFamily="34" charset="-120"/>
-              </a:rPr>
-              <a:t>Apr-27</a:t>
-            </a:r>
-            <a:endParaRPr lang="en-US" sz="900" dirty="0"/>
-          </a:p>
-        </p:txBody>
-      </p:sp>
-      <p:sp>
-        <p:nvSpPr>
-          <p:cNvPr id="136" name="Milestone Apr-27 marker"/>
-          <p:cNvSpPr/>
-          <p:nvPr/>
-        </p:nvSpPr>
-        <p:spPr>
-          <a:xfrm>
-            <a:off x="8179308" y="5815584"/>
-            <a:ext cx="91440" cy="91440"/>
-          </a:xfrm>
-          <a:prstGeom prst="ellipse">
-            <a:avLst/>
-          </a:prstGeom>
-          <a:solidFill>
-            <a:srgbClr val="A3B1C6"/>
-          </a:solidFill>
-          <a:ln w="12700">
-            <a:solidFill>
-              <a:srgbClr val="FFFFFF"/>
-            </a:solidFill>
-            <a:prstDash val="solid"/>
-          </a:ln>
-        </p:spPr>
-      </p:sp>
-      <p:sp>
-        <p:nvSpPr>
-          <p:cNvPr id="137" name="Milestone May-27 label"/>
-          <p:cNvSpPr txBox="1"/>
-          <p:nvPr/>
-        </p:nvSpPr>
-        <p:spPr>
-          <a:xfrm>
-            <a:off x="8801100" y="5614416"/>
-            <a:ext cx="731520" cy="164592"/>
-          </a:xfrm>
-          <a:prstGeom prst="rect">
-            <a:avLst/>
-          </a:prstGeom>
-          <a:noFill/>
-          <a:ln/>
-        </p:spPr>
-        <p:txBody>
-          <a:bodyPr wrap="square" lIns="0" tIns="0" rIns="0" bIns="0" rtlCol="0" anchor="ctr"/>
-          <a:lstStyle/>
-          <a:p>
-            <a:pPr algn="ctr" indent="0" marL="0">
-              <a:buNone/>
-            </a:pPr>
-            <a:r>
-              <a:rPr lang="en-US" sz="900" dirty="0">
-                <a:solidFill>
-                  <a:srgbClr val="374151"/>
-                </a:solidFill>
-                <a:latin typeface="Calibri" pitchFamily="34" charset="0"/>
-                <a:ea typeface="Calibri" pitchFamily="34" charset="-122"/>
-                <a:cs typeface="Calibri" pitchFamily="34" charset="-120"/>
-              </a:rPr>
-              <a:t>May-27</a:t>
-            </a:r>
-            <a:endParaRPr lang="en-US" sz="900" dirty="0"/>
-          </a:p>
-        </p:txBody>
-      </p:sp>
-      <p:sp>
-        <p:nvSpPr>
-          <p:cNvPr id="138" name="Milestone May-27 marker"/>
-          <p:cNvSpPr/>
-          <p:nvPr/>
-        </p:nvSpPr>
-        <p:spPr>
-          <a:xfrm>
-            <a:off x="9107424" y="5801868"/>
-            <a:ext cx="118872" cy="118872"/>
-          </a:xfrm>
-          <a:prstGeom prst="ellipse">
-            <a:avLst/>
-          </a:prstGeom>
-          <a:solidFill>
-            <a:srgbClr val="14285A"/>
-          </a:solidFill>
-          <a:ln w="12700">
-            <a:solidFill>
-              <a:srgbClr val="FFFFFF"/>
-            </a:solidFill>
-            <a:prstDash val="solid"/>
-          </a:ln>
-        </p:spPr>
-      </p:sp>
-      <p:sp>
-        <p:nvSpPr>
-          <p:cNvPr id="139" name="Milestones May-27"/>
-          <p:cNvSpPr txBox="1"/>
-          <p:nvPr/>
-        </p:nvSpPr>
-        <p:spPr>
-          <a:xfrm>
-            <a:off x="9121140" y="5952744"/>
-            <a:ext cx="1737360" cy="502920"/>
-          </a:xfrm>
-          <a:prstGeom prst="rect">
-            <a:avLst/>
-          </a:prstGeom>
-          <a:noFill/>
-          <a:ln/>
-        </p:spPr>
-        <p:txBody>
-          <a:bodyPr wrap="square" lIns="0" tIns="0" rIns="0" bIns="0" rtlCol="0" anchor="t"/>
-          <a:lstStyle/>
-          <a:p>
-            <a:pPr marL="114300" indent="-114300">
-              <a:buSzPct val="100000"/>
-              <a:buChar char="●"/>
-            </a:pPr>
-            <a:r>
-              <a:rPr lang="en-US" sz="800" dirty="0">
-                <a:solidFill>
-                  <a:srgbClr val="1F2937"/>
-                </a:solidFill>
-                <a:latin typeface="Calibri" pitchFamily="34" charset="0"/>
-                <a:ea typeface="Calibri" pitchFamily="34" charset="-122"/>
-                <a:cs typeface="Calibri" pitchFamily="34" charset="-120"/>
-              </a:rPr>
-              <a:t>ME SDP Release 3 Go Live</a:t>
-            </a:r>
-            <a:endParaRPr lang="en-US" sz="800" dirty="0"/>
-          </a:p>
-        </p:txBody>
-      </p:sp>
-      <p:sp>
-        <p:nvSpPr>
-          <p:cNvPr id="140" name="Milestone Jun-27 label"/>
-          <p:cNvSpPr txBox="1"/>
-          <p:nvPr/>
-        </p:nvSpPr>
-        <p:spPr>
-          <a:xfrm>
-            <a:off x="9742932" y="5614416"/>
-            <a:ext cx="731520" cy="164592"/>
-          </a:xfrm>
-          <a:prstGeom prst="rect">
-            <a:avLst/>
-          </a:prstGeom>
-          <a:noFill/>
-          <a:ln/>
-        </p:spPr>
-        <p:txBody>
-          <a:bodyPr wrap="square" lIns="0" tIns="0" rIns="0" bIns="0" rtlCol="0" anchor="ctr"/>
-          <a:lstStyle/>
-          <a:p>
-            <a:pPr algn="ctr" indent="0" marL="0">
-              <a:buNone/>
-            </a:pPr>
-            <a:r>
-              <a:rPr lang="en-US" sz="900" dirty="0">
-                <a:solidFill>
-                  <a:srgbClr val="374151"/>
-                </a:solidFill>
-                <a:latin typeface="Calibri" pitchFamily="34" charset="0"/>
-                <a:ea typeface="Calibri" pitchFamily="34" charset="-122"/>
-                <a:cs typeface="Calibri" pitchFamily="34" charset="-120"/>
-              </a:rPr>
-              <a:t>Jun-27</a:t>
-            </a:r>
-            <a:endParaRPr lang="en-US" sz="900" dirty="0"/>
-          </a:p>
-        </p:txBody>
-      </p:sp>
-      <p:sp>
-        <p:nvSpPr>
-          <p:cNvPr id="141" name="Milestone Jun-27 marker"/>
-          <p:cNvSpPr/>
-          <p:nvPr/>
-        </p:nvSpPr>
-        <p:spPr>
-          <a:xfrm>
-            <a:off x="10062972" y="5815584"/>
-            <a:ext cx="91440" cy="91440"/>
-          </a:xfrm>
-          <a:prstGeom prst="ellipse">
-            <a:avLst/>
-          </a:prstGeom>
-          <a:solidFill>
-            <a:srgbClr val="A3B1C6"/>
-          </a:solidFill>
-          <a:ln w="12700">
-            <a:solidFill>
-              <a:srgbClr val="FFFFFF"/>
-            </a:solidFill>
-            <a:prstDash val="solid"/>
-          </a:ln>
-        </p:spPr>
-      </p:sp>
-      <p:sp>
-        <p:nvSpPr>
-          <p:cNvPr id="142" name="Footnote"/>
+          <p:cNvPr id="141" name="Footnote"/>
           <p:cNvSpPr txBox="1"/>
           <p:nvPr/>
         </p:nvSpPr>
@@ -6170,7 +6082,7 @@
       </p:sp>
       <p:sp>
         <p:nvSpPr>
-          <p:cNvPr id="143" name="Legend Release 1 swatch"/>
+          <p:cNvPr id="142" name="Legend Release 1 swatch"/>
           <p:cNvSpPr/>
           <p:nvPr/>
         </p:nvSpPr>
@@ -6197,7 +6109,7 @@
       </p:sp>
       <p:sp>
         <p:nvSpPr>
-          <p:cNvPr id="144" name="Legend Release 1"/>
+          <p:cNvPr id="143" name="Legend Release 1"/>
           <p:cNvSpPr txBox="1"/>
           <p:nvPr/>
         </p:nvSpPr>
@@ -6236,7 +6148,7 @@
       </p:sp>
       <p:sp>
         <p:nvSpPr>
-          <p:cNvPr id="145" name="Legend Release 2 swatch"/>
+          <p:cNvPr id="144" name="Legend Release 2 swatch"/>
           <p:cNvSpPr/>
           <p:nvPr/>
         </p:nvSpPr>
@@ -6263,7 +6175,7 @@
       </p:sp>
       <p:sp>
         <p:nvSpPr>
-          <p:cNvPr id="146" name="Legend Release 2"/>
+          <p:cNvPr id="145" name="Legend Release 2"/>
           <p:cNvSpPr txBox="1"/>
           <p:nvPr/>
         </p:nvSpPr>
@@ -6302,7 +6214,7 @@
       </p:sp>
       <p:sp>
         <p:nvSpPr>
-          <p:cNvPr id="147" name="Legend Release 3 swatch"/>
+          <p:cNvPr id="146" name="Legend Release 3 swatch"/>
           <p:cNvSpPr/>
           <p:nvPr/>
         </p:nvSpPr>
@@ -6329,7 +6241,7 @@
       </p:sp>
       <p:sp>
         <p:nvSpPr>
-          <p:cNvPr id="148" name="Legend Release 3"/>
+          <p:cNvPr id="147" name="Legend Release 3"/>
           <p:cNvSpPr txBox="1"/>
           <p:nvPr/>
         </p:nvSpPr>
@@ -6368,7 +6280,7 @@
       </p:sp>
       <p:sp>
         <p:nvSpPr>
-          <p:cNvPr id="149" name="Legend TBD swatch"/>
+          <p:cNvPr id="148" name="Legend TBD swatch"/>
           <p:cNvSpPr/>
           <p:nvPr/>
         </p:nvSpPr>
@@ -6395,7 +6307,7 @@
       </p:sp>
       <p:sp>
         <p:nvSpPr>
-          <p:cNvPr id="150" name="Legend TBD"/>
+          <p:cNvPr id="149" name="Legend TBD"/>
           <p:cNvSpPr txBox="1"/>
           <p:nvPr/>
         </p:nvSpPr>

</xml_diff>